<commit_message>
research: Latent Reasoning에 RecursiveMAS (arXiv 2604.25917) 추가 - 2026-05-18
- RecursiveMAS: Multi-Agent System으로 Latent Reasoning을 확장
  (Inner/Outer RecursiveLink, Inner-Outer Loop 학습, 4가지 협업 패턴)
- 블로그: 7번 섹션 신설, 종합 지형도를 5가지 흐름으로 확장, 미해결 과제 갱신
- 슬라이드: RecursiveMAS 메커니즘/결과 슬라이드 2장 추가, 5가지 흐름 종합 슬라이드 갱신
- 참고문헌 XLSX: 논문/프로젝트 페이지/GitHub 3개 항목 추가
- index.md 홈페이지 항목을 2026-05-18 업데이트 표기로 변경

Co-Authored-By: Claude Opus 4.7 (1M context) <noreply@anthropic.com>
</commit_message>
<xml_diff>
--- a/2026-05-08-latent-reasoning/latent-reasoning-presentation.pptx
+++ b/2026-05-08-latent-reasoning/latent-reasoning-presentation.pptx
@@ -16,6 +16,8 @@
     <p:sldId id="264" r:id="rId10"/>
     <p:sldId id="265" r:id="rId11"/>
     <p:sldId id="266" r:id="rId12"/>
+    <p:sldId id="270" r:id="rId21"/>
+    <p:sldId id="271" r:id="rId22"/>
     <p:sldId id="267" r:id="rId13"/>
     <p:sldId id="268" r:id="rId14"/>
     <p:sldId id="269" r:id="rId15"/>
@@ -2056,6 +2058,10 @@
             <a:prstDash val="solid"/>
           </a:ln>
         </p:spPr>
+        <p:txBody>
+          <a:bodyPr/>
+          <a:p/>
+        </p:txBody>
       </p:sp>
       <p:sp>
         <p:nvSpPr>
@@ -2081,6 +2087,10 @@
             <a:prstDash val="solid"/>
           </a:ln>
         </p:spPr>
+        <p:txBody>
+          <a:bodyPr/>
+          <a:p/>
+        </p:txBody>
       </p:sp>
       <p:sp>
         <p:nvSpPr>
@@ -2614,6 +2624,10 @@
             <a:prstDash val="solid"/>
           </a:ln>
         </p:spPr>
+        <p:txBody>
+          <a:bodyPr/>
+          <a:p/>
+        </p:txBody>
       </p:sp>
       <p:sp>
         <p:nvSpPr>
@@ -4677,6 +4691,10 @@
             <a:prstDash val="solid"/>
           </a:ln>
         </p:spPr>
+        <p:txBody>
+          <a:bodyPr/>
+          <a:p/>
+        </p:txBody>
       </p:sp>
       <p:sp>
         <p:nvSpPr>
@@ -5389,6 +5407,2577 @@
 </file>
 
 <file path=ppt/slides/slide12.xml><?xml version="1.0" encoding="utf-8"?>
+<p:sld xmlns:a="http://schemas.openxmlformats.org/drawingml/2006/main" xmlns:p="http://schemas.openxmlformats.org/presentationml/2006/main" xmlns:r="http://schemas.openxmlformats.org/officeDocument/2006/relationships">
+  <p:cSld>
+    <p:spTree>
+      <p:nvGrpSpPr>
+        <p:cNvPr id="1" name=""/>
+        <p:cNvGrpSpPr/>
+        <p:nvPr/>
+      </p:nvGrpSpPr>
+      <p:grpSpPr/>
+      <p:sp>
+        <p:nvSpPr>
+          <p:cNvPr id="2" name="Shape 0"/>
+          <p:cNvSpPr/>
+          <p:nvPr/>
+        </p:nvSpPr>
+        <p:spPr>
+          <a:xfrm>
+            <a:off x="0" y="0"/>
+            <a:ext cx="9144000" cy="54864"/>
+          </a:xfrm>
+          <a:prstGeom prst="rect">
+            <a:avLst/>
+          </a:prstGeom>
+          <a:solidFill>
+            <a:srgbClr val="0F1E3C"/>
+          </a:solidFill>
+          <a:ln w="12700">
+            <a:solidFill>
+              <a:srgbClr val="0F1E3C"/>
+            </a:solidFill>
+            <a:prstDash val="solid"/>
+          </a:ln>
+        </p:spPr>
+        <p:txBody>
+          <a:bodyPr/>
+          <a:p/>
+        </p:txBody>
+      </p:sp>
+      <p:sp>
+        <p:nvSpPr>
+          <p:cNvPr id="3" name="Text 1"/>
+          <p:cNvSpPr/>
+          <p:nvPr/>
+        </p:nvSpPr>
+        <p:spPr>
+          <a:xfrm>
+            <a:off x="502920" y="164592"/>
+            <a:ext cx="8138160" cy="594360"/>
+          </a:xfrm>
+          <a:prstGeom prst="rect">
+            <a:avLst/>
+          </a:prstGeom>
+          <a:noFill/>
+          <a:ln/>
+        </p:spPr>
+        <p:txBody>
+          <a:bodyPr wrap="square" lIns="0" tIns="0" rIns="0" bIns="0" rtlCol="0" anchor="ctr"/>
+          <a:lstStyle/>
+          <a:p>
+            <a:pPr indent="0" marL="0">
+              <a:buNone/>
+            </a:pPr>
+            <a:r>
+              <a:rPr lang="en-US" sz="2600" b="1" dirty="0">
+                <a:solidFill>
+                  <a:srgbClr val="0F1E3C"/>
+                </a:solidFill>
+                <a:latin typeface="Malgun Gothic" pitchFamily="34" charset="0"/>
+                <a:ea typeface="Malgun Gothic" pitchFamily="34" charset="-122"/>
+                <a:cs typeface="Malgun Gothic" pitchFamily="34" charset="-120"/>
+              </a:rPr>
+              <a:t>RecursiveMAS: Multi-Agent를 Latent로 묶기</a:t>
+            </a:r>
+            <a:endParaRPr lang="en-US" sz="2600" dirty="0"/>
+          </a:p>
+        </p:txBody>
+      </p:sp>
+      <p:sp>
+        <p:nvSpPr>
+          <p:cNvPr id="4" name="Shape 2"/>
+          <p:cNvSpPr/>
+          <p:nvPr/>
+        </p:nvSpPr>
+        <p:spPr>
+          <a:xfrm>
+            <a:off x="502920" y="777240"/>
+            <a:ext cx="1097280" cy="41148"/>
+          </a:xfrm>
+          <a:prstGeom prst="rect">
+            <a:avLst/>
+          </a:prstGeom>
+          <a:solidFill>
+            <a:srgbClr val="F97316"/>
+          </a:solidFill>
+          <a:ln w="12700">
+            <a:solidFill>
+              <a:srgbClr val="F97316"/>
+            </a:solidFill>
+            <a:prstDash val="solid"/>
+          </a:ln>
+        </p:spPr>
+      </p:sp>
+      <p:sp>
+        <p:nvSpPr>
+          <p:cNvPr id="5" name="Shape 3"/>
+          <p:cNvSpPr/>
+          <p:nvPr/>
+        </p:nvSpPr>
+        <p:spPr>
+          <a:xfrm>
+            <a:off x="457200" y="960120"/>
+            <a:ext cx="3840480" cy="1737360"/>
+          </a:xfrm>
+          <a:prstGeom prst="rect">
+            <a:avLst/>
+          </a:prstGeom>
+          <a:solidFill>
+            <a:srgbClr val="FFFFFF"/>
+          </a:solidFill>
+          <a:ln w="12700">
+            <a:solidFill>
+              <a:srgbClr val="E2E8F0"/>
+            </a:solidFill>
+            <a:prstDash val="solid"/>
+          </a:ln>
+          <a:effectLst>
+            <a:outerShdw sx="100000" sy="100000" kx="0" ky="0" algn="bl" rotWithShape="0" blurRad="101600" dist="38100" dir="8100000">
+              <a:srgbClr val="000000">
+                <a:alpha val="18000"/>
+              </a:srgbClr>
+            </a:outerShdw>
+          </a:effectLst>
+        </p:spPr>
+      </p:sp>
+      <p:sp>
+        <p:nvSpPr>
+          <p:cNvPr id="6" name="Shape 4"/>
+          <p:cNvSpPr/>
+          <p:nvPr/>
+        </p:nvSpPr>
+        <p:spPr>
+          <a:xfrm>
+            <a:off x="457200" y="960120"/>
+            <a:ext cx="3840480" cy="292608"/>
+          </a:xfrm>
+          <a:prstGeom prst="rect">
+            <a:avLst/>
+          </a:prstGeom>
+          <a:solidFill>
+            <a:srgbClr val="64748B"/>
+          </a:solidFill>
+          <a:ln w="12700">
+            <a:solidFill>
+              <a:srgbClr val="64748B"/>
+            </a:solidFill>
+            <a:prstDash val="solid"/>
+          </a:ln>
+        </p:spPr>
+      </p:sp>
+      <p:sp>
+        <p:nvSpPr>
+          <p:cNvPr id="7" name="Text 5"/>
+          <p:cNvSpPr/>
+          <p:nvPr/>
+        </p:nvSpPr>
+        <p:spPr>
+          <a:xfrm>
+            <a:off x="457200" y="960120"/>
+            <a:ext cx="3840480" cy="292608"/>
+          </a:xfrm>
+          <a:prstGeom prst="rect">
+            <a:avLst/>
+          </a:prstGeom>
+          <a:noFill/>
+          <a:ln/>
+        </p:spPr>
+        <p:txBody>
+          <a:bodyPr wrap="square" lIns="0" tIns="0" rIns="0" bIns="0" rtlCol="0" anchor="ctr"/>
+          <a:lstStyle/>
+          <a:p>
+            <a:pPr algn="ctr" indent="0" marL="0">
+              <a:buNone/>
+            </a:pPr>
+            <a:r>
+              <a:rPr lang="en-US" sz="1100" b="1" dirty="0">
+                <a:solidFill>
+                  <a:srgbClr val="FFFFFF"/>
+                </a:solidFill>
+                <a:latin typeface="Malgun Gothic" pitchFamily="34" charset="0"/>
+                <a:ea typeface="Malgun Gothic" pitchFamily="34" charset="-122"/>
+                <a:cs typeface="Malgun Gothic" pitchFamily="34" charset="-120"/>
+              </a:rPr>
+              <a:t>기존 Multi-Agent System</a:t>
+            </a:r>
+            <a:endParaRPr lang="en-US" sz="1100" dirty="0"/>
+          </a:p>
+        </p:txBody>
+      </p:sp>
+      <p:sp>
+        <p:nvSpPr>
+          <p:cNvPr id="8" name="Text 6"/>
+          <p:cNvSpPr/>
+          <p:nvPr/>
+        </p:nvSpPr>
+        <p:spPr>
+          <a:xfrm>
+            <a:off x="594360" y="1325880"/>
+            <a:ext cx="3566160" cy="347472"/>
+          </a:xfrm>
+          <a:prstGeom prst="rect">
+            <a:avLst/>
+          </a:prstGeom>
+          <a:noFill/>
+          <a:ln/>
+        </p:spPr>
+        <p:txBody>
+          <a:bodyPr wrap="square" lIns="0" tIns="0" rIns="0" bIns="0" rtlCol="0" anchor="ctr"/>
+          <a:lstStyle/>
+          <a:p>
+            <a:pPr indent="0" marL="0">
+              <a:buNone/>
+            </a:pPr>
+            <a:r>
+              <a:rPr lang="en-US" sz="1100" dirty="0">
+                <a:solidFill>
+                  <a:srgbClr val="2D3748"/>
+                </a:solidFill>
+                <a:latin typeface="Consolas" pitchFamily="34" charset="0"/>
+                <a:ea typeface="Consolas" pitchFamily="34" charset="-122"/>
+                <a:cs typeface="Consolas" pitchFamily="34" charset="-120"/>
+              </a:rPr>
+              <a:t>Agent A -&gt; 텍스트 -&gt; Agent B -&gt; 텍스트 -&gt; ...</a:t>
+            </a:r>
+            <a:endParaRPr lang="en-US" sz="1100" dirty="0"/>
+          </a:p>
+        </p:txBody>
+      </p:sp>
+      <p:sp>
+        <p:nvSpPr>
+          <p:cNvPr id="9" name="Text 7"/>
+          <p:cNvSpPr/>
+          <p:nvPr/>
+        </p:nvSpPr>
+        <p:spPr>
+          <a:xfrm>
+            <a:off x="594360" y="1719072"/>
+            <a:ext cx="3566160" cy="320040"/>
+          </a:xfrm>
+          <a:prstGeom prst="rect">
+            <a:avLst/>
+          </a:prstGeom>
+          <a:noFill/>
+          <a:ln/>
+        </p:spPr>
+        <p:txBody>
+          <a:bodyPr wrap="square" lIns="0" tIns="0" rIns="0" bIns="0" rtlCol="0" anchor="ctr"/>
+          <a:lstStyle/>
+          <a:p>
+            <a:pPr indent="0" marL="0">
+              <a:buNone/>
+            </a:pPr>
+            <a:r>
+              <a:rPr lang="en-US" sz="1000" i="1" dirty="0">
+                <a:solidFill>
+                  <a:srgbClr val="EF4444"/>
+                </a:solidFill>
+                <a:latin typeface="Malgun Gothic" pitchFamily="34" charset="0"/>
+                <a:ea typeface="Malgun Gothic" pitchFamily="34" charset="-122"/>
+                <a:cs typeface="Malgun Gothic" pitchFamily="34" charset="-120"/>
+              </a:rPr>
+              <a:t>매 경계마다 vocab projection 병목</a:t>
+            </a:r>
+            <a:endParaRPr lang="en-US" sz="1000" dirty="0"/>
+          </a:p>
+        </p:txBody>
+      </p:sp>
+      <p:sp>
+        <p:nvSpPr>
+          <p:cNvPr id="10" name="Text 8"/>
+          <p:cNvSpPr/>
+          <p:nvPr/>
+        </p:nvSpPr>
+        <p:spPr>
+          <a:xfrm>
+            <a:off x="594360" y="2084832"/>
+            <a:ext cx="3566160" cy="320040"/>
+          </a:xfrm>
+          <a:prstGeom prst="rect">
+            <a:avLst/>
+          </a:prstGeom>
+          <a:noFill/>
+          <a:ln/>
+        </p:spPr>
+        <p:txBody>
+          <a:bodyPr wrap="square" lIns="0" tIns="0" rIns="0" bIns="0" rtlCol="0" anchor="ctr"/>
+          <a:lstStyle/>
+          <a:p>
+            <a:pPr indent="0" marL="0">
+              <a:buNone/>
+            </a:pPr>
+            <a:r>
+              <a:rPr lang="en-US" sz="900" dirty="0">
+                <a:solidFill>
+                  <a:srgbClr val="64748B"/>
+                </a:solidFill>
+                <a:latin typeface="Malgun Gothic" pitchFamily="34" charset="0"/>
+                <a:ea typeface="Malgun Gothic" pitchFamily="34" charset="-122"/>
+                <a:cs typeface="Malgun Gothic" pitchFamily="34" charset="-120"/>
+              </a:rPr>
+              <a:t>Agent 수 x Round 수 만큼 토큰 손실 누적</a:t>
+            </a:r>
+            <a:endParaRPr lang="en-US" sz="900" dirty="0"/>
+          </a:p>
+        </p:txBody>
+      </p:sp>
+      <p:sp>
+        <p:nvSpPr>
+          <p:cNvPr id="11" name="Shape 9"/>
+          <p:cNvSpPr/>
+          <p:nvPr/>
+        </p:nvSpPr>
+        <p:spPr>
+          <a:xfrm>
+            <a:off x="457200" y="2834640"/>
+            <a:ext cx="3840480" cy="1737360"/>
+          </a:xfrm>
+          <a:prstGeom prst="rect">
+            <a:avLst/>
+          </a:prstGeom>
+          <a:solidFill>
+            <a:srgbClr val="FFFFFF"/>
+          </a:solidFill>
+          <a:ln w="25400">
+            <a:solidFill>
+              <a:srgbClr val="F97316"/>
+            </a:solidFill>
+            <a:prstDash val="solid"/>
+          </a:ln>
+          <a:effectLst>
+            <a:outerShdw sx="100000" sy="100000" kx="0" ky="0" algn="bl" rotWithShape="0" blurRad="101600" dist="38100" dir="8100000">
+              <a:srgbClr val="000000">
+                <a:alpha val="18000"/>
+              </a:srgbClr>
+            </a:outerShdw>
+          </a:effectLst>
+        </p:spPr>
+      </p:sp>
+      <p:sp>
+        <p:nvSpPr>
+          <p:cNvPr id="12" name="Shape 10"/>
+          <p:cNvSpPr/>
+          <p:nvPr/>
+        </p:nvSpPr>
+        <p:spPr>
+          <a:xfrm>
+            <a:off x="457200" y="2834640"/>
+            <a:ext cx="3840480" cy="292608"/>
+          </a:xfrm>
+          <a:prstGeom prst="rect">
+            <a:avLst/>
+          </a:prstGeom>
+          <a:solidFill>
+            <a:srgbClr val="F97316"/>
+          </a:solidFill>
+          <a:ln w="12700">
+            <a:solidFill>
+              <a:srgbClr val="F97316"/>
+            </a:solidFill>
+            <a:prstDash val="solid"/>
+          </a:ln>
+        </p:spPr>
+      </p:sp>
+      <p:sp>
+        <p:nvSpPr>
+          <p:cNvPr id="13" name="Text 11"/>
+          <p:cNvSpPr/>
+          <p:nvPr/>
+        </p:nvSpPr>
+        <p:spPr>
+          <a:xfrm>
+            <a:off x="457200" y="2834640"/>
+            <a:ext cx="3840480" cy="292608"/>
+          </a:xfrm>
+          <a:prstGeom prst="rect">
+            <a:avLst/>
+          </a:prstGeom>
+          <a:noFill/>
+          <a:ln/>
+        </p:spPr>
+        <p:txBody>
+          <a:bodyPr wrap="square" lIns="0" tIns="0" rIns="0" bIns="0" rtlCol="0" anchor="ctr"/>
+          <a:lstStyle/>
+          <a:p>
+            <a:pPr algn="ctr" indent="0" marL="0">
+              <a:buNone/>
+            </a:pPr>
+            <a:r>
+              <a:rPr lang="en-US" sz="1000" b="1" dirty="0">
+                <a:solidFill>
+                  <a:srgbClr val="FFFFFF"/>
+                </a:solidFill>
+                <a:latin typeface="Malgun Gothic" pitchFamily="34" charset="0"/>
+                <a:ea typeface="Malgun Gothic" pitchFamily="34" charset="-122"/>
+                <a:cs typeface="Malgun Gothic" pitchFamily="34" charset="-120"/>
+              </a:rPr>
+              <a:t>RecursiveMAS</a:t>
+            </a:r>
+            <a:endParaRPr lang="en-US" sz="1000" dirty="0"/>
+          </a:p>
+        </p:txBody>
+      </p:sp>
+      <p:sp>
+        <p:nvSpPr>
+          <p:cNvPr id="14" name="Text 12"/>
+          <p:cNvSpPr/>
+          <p:nvPr/>
+        </p:nvSpPr>
+        <p:spPr>
+          <a:xfrm>
+            <a:off x="594360" y="3218688"/>
+            <a:ext cx="3566160" cy="347472"/>
+          </a:xfrm>
+          <a:prstGeom prst="rect">
+            <a:avLst/>
+          </a:prstGeom>
+          <a:noFill/>
+          <a:ln/>
+        </p:spPr>
+        <p:txBody>
+          <a:bodyPr wrap="square" lIns="0" tIns="0" rIns="0" bIns="0" rtlCol="0" anchor="ctr"/>
+          <a:lstStyle/>
+          <a:p>
+            <a:pPr indent="0" marL="0">
+              <a:buNone/>
+            </a:pPr>
+            <a:r>
+              <a:rPr lang="en-US" sz="1300" dirty="0">
+                <a:solidFill>
+                  <a:srgbClr val="2D3748"/>
+                </a:solidFill>
+                <a:latin typeface="Consolas" pitchFamily="34" charset="0"/>
+                <a:ea typeface="Consolas" pitchFamily="34" charset="-122"/>
+                <a:cs typeface="Consolas" pitchFamily="34" charset="-120"/>
+              </a:rPr>
+              <a:t>Agent A -&gt; (RecursiveLink) -&gt; Agent B -&gt; ...</a:t>
+            </a:r>
+            <a:endParaRPr lang="en-US" sz="1300" dirty="0"/>
+          </a:p>
+        </p:txBody>
+      </p:sp>
+      <p:sp>
+        <p:nvSpPr>
+          <p:cNvPr id="15" name="Text 13"/>
+          <p:cNvSpPr/>
+          <p:nvPr/>
+        </p:nvSpPr>
+        <p:spPr>
+          <a:xfrm>
+            <a:off x="594360" y="3602736"/>
+            <a:ext cx="3566160" cy="320040"/>
+          </a:xfrm>
+          <a:prstGeom prst="rect">
+            <a:avLst/>
+          </a:prstGeom>
+          <a:noFill/>
+          <a:ln/>
+        </p:spPr>
+        <p:txBody>
+          <a:bodyPr wrap="square" lIns="0" tIns="0" rIns="0" bIns="0" rtlCol="0" anchor="ctr"/>
+          <a:lstStyle/>
+          <a:p>
+            <a:pPr indent="0" marL="0">
+              <a:buNone/>
+            </a:pPr>
+            <a:r>
+              <a:rPr lang="en-US" sz="1000" b="1" i="1" dirty="0">
+                <a:solidFill>
+                  <a:srgbClr val="10B981"/>
+                </a:solidFill>
+                <a:latin typeface="Malgun Gothic" pitchFamily="34" charset="0"/>
+                <a:ea typeface="Malgun Gothic" pitchFamily="34" charset="-122"/>
+                <a:cs typeface="Malgun Gothic" pitchFamily="34" charset="-120"/>
+              </a:rPr>
+              <a:t>최종 round만 텍스트로 디코딩</a:t>
+            </a:r>
+            <a:endParaRPr lang="en-US" sz="1000" dirty="0"/>
+          </a:p>
+        </p:txBody>
+      </p:sp>
+      <p:sp>
+        <p:nvSpPr>
+          <p:cNvPr id="16" name="Text 14"/>
+          <p:cNvSpPr/>
+          <p:nvPr/>
+        </p:nvSpPr>
+        <p:spPr>
+          <a:xfrm>
+            <a:off x="594360" y="3968496"/>
+            <a:ext cx="3566160" cy="320040"/>
+          </a:xfrm>
+          <a:prstGeom prst="rect">
+            <a:avLst/>
+          </a:prstGeom>
+          <a:noFill/>
+          <a:ln/>
+        </p:spPr>
+        <p:txBody>
+          <a:bodyPr wrap="square" lIns="0" tIns="0" rIns="0" bIns="0" rtlCol="0" anchor="ctr"/>
+          <a:lstStyle/>
+          <a:p>
+            <a:pPr indent="0" marL="0">
+              <a:buNone/>
+            </a:pPr>
+            <a:r>
+              <a:rPr lang="en-US" sz="900" dirty="0">
+                <a:solidFill>
+                  <a:srgbClr val="64748B"/>
+                </a:solidFill>
+                <a:latin typeface="Malgun Gothic" pitchFamily="34" charset="0"/>
+                <a:ea typeface="Malgun Gothic" pitchFamily="34" charset="-122"/>
+                <a:cs typeface="Malgun Gothic" pitchFamily="34" charset="-120"/>
+              </a:rPr>
+              <a:t>중간 통신은 모두 latent space에서 협업</a:t>
+            </a:r>
+            <a:endParaRPr lang="en-US" sz="900" dirty="0"/>
+          </a:p>
+        </p:txBody>
+      </p:sp>
+      <p:sp>
+        <p:nvSpPr>
+          <p:cNvPr id="17" name="Shape 15"/>
+          <p:cNvSpPr/>
+          <p:nvPr/>
+        </p:nvSpPr>
+        <p:spPr>
+          <a:xfrm>
+            <a:off x="4572000" y="960120"/>
+            <a:ext cx="4114800" cy="3611880"/>
+          </a:xfrm>
+          <a:prstGeom prst="rect">
+            <a:avLst/>
+          </a:prstGeom>
+          <a:solidFill>
+            <a:srgbClr val="0F1E3C"/>
+          </a:solidFill>
+          <a:ln w="19050">
+            <a:solidFill>
+              <a:srgbClr val="4FA3E0"/>
+            </a:solidFill>
+            <a:prstDash val="solid"/>
+          </a:ln>
+          <a:effectLst>
+            <a:outerShdw sx="100000" sy="100000" kx="0" ky="0" algn="bl" rotWithShape="0" blurRad="101600" dist="38100" dir="8100000">
+              <a:srgbClr val="000000">
+                <a:alpha val="18000"/>
+              </a:srgbClr>
+            </a:outerShdw>
+          </a:effectLst>
+        </p:spPr>
+      </p:sp>
+      <p:sp>
+        <p:nvSpPr>
+          <p:cNvPr id="18" name="Text 16"/>
+          <p:cNvSpPr/>
+          <p:nvPr/>
+        </p:nvSpPr>
+        <p:spPr>
+          <a:xfrm>
+            <a:off x="4709160" y="1078992"/>
+            <a:ext cx="3840480" cy="320040"/>
+          </a:xfrm>
+          <a:prstGeom prst="rect">
+            <a:avLst/>
+          </a:prstGeom>
+          <a:noFill/>
+          <a:ln/>
+        </p:spPr>
+        <p:txBody>
+          <a:bodyPr wrap="square" lIns="0" tIns="0" rIns="0" bIns="0" rtlCol="0" anchor="ctr"/>
+          <a:lstStyle/>
+          <a:p>
+            <a:pPr indent="0" marL="0">
+              <a:buNone/>
+            </a:pPr>
+            <a:r>
+              <a:rPr lang="en-US" sz="1300" b="1" dirty="0">
+                <a:solidFill>
+                  <a:srgbClr val="4FA3E0"/>
+                </a:solidFill>
+                <a:latin typeface="Malgun Gothic" pitchFamily="34" charset="0"/>
+                <a:ea typeface="Malgun Gothic" pitchFamily="34" charset="-122"/>
+                <a:cs typeface="Malgun Gothic" pitchFamily="34" charset="-120"/>
+              </a:rPr>
+              <a:t>RecursiveLink (lightweight)</a:t>
+            </a:r>
+            <a:endParaRPr lang="en-US" sz="1300" dirty="0"/>
+          </a:p>
+        </p:txBody>
+      </p:sp>
+      <p:sp>
+        <p:nvSpPr>
+          <p:cNvPr id="19" name="Text 17"/>
+          <p:cNvSpPr/>
+          <p:nvPr/>
+        </p:nvSpPr>
+        <p:spPr>
+          <a:xfrm>
+            <a:off x="4754880" y="1463040"/>
+            <a:ext cx="3840480" cy="256032"/>
+          </a:xfrm>
+          <a:prstGeom prst="rect">
+            <a:avLst/>
+          </a:prstGeom>
+          <a:noFill/>
+          <a:ln/>
+        </p:spPr>
+        <p:txBody>
+          <a:bodyPr wrap="square" lIns="0" tIns="0" rIns="0" bIns="0" rtlCol="0" anchor="ctr"/>
+          <a:lstStyle/>
+          <a:p>
+            <a:pPr indent="0" marL="0">
+              <a:buNone/>
+            </a:pPr>
+            <a:r>
+              <a:rPr lang="en-US" sz="1200" dirty="0">
+                <a:solidFill>
+                  <a:srgbClr val="FFFFFF"/>
+                </a:solidFill>
+                <a:latin typeface="Malgun Gothic" pitchFamily="34" charset="0"/>
+                <a:ea typeface="Malgun Gothic" pitchFamily="34" charset="-122"/>
+                <a:cs typeface="Malgun Gothic" pitchFamily="34" charset="-120"/>
+              </a:rPr>
+              <a:t>Inner: R(h) = h + W2 sigma(W1 h)</a:t>
+            </a:r>
+            <a:endParaRPr lang="en-US" sz="1200" dirty="0"/>
+          </a:p>
+        </p:txBody>
+      </p:sp>
+      <p:sp>
+        <p:nvSpPr>
+          <p:cNvPr id="20" name="Text 18"/>
+          <p:cNvSpPr/>
+          <p:nvPr/>
+        </p:nvSpPr>
+        <p:spPr>
+          <a:xfrm>
+            <a:off x="4754880" y="1737360"/>
+            <a:ext cx="3840480" cy="256032"/>
+          </a:xfrm>
+          <a:prstGeom prst="rect">
+            <a:avLst/>
+          </a:prstGeom>
+          <a:noFill/>
+          <a:ln/>
+        </p:spPr>
+        <p:txBody>
+          <a:bodyPr wrap="square" lIns="0" tIns="0" rIns="0" bIns="0" rtlCol="0" anchor="ctr"/>
+          <a:lstStyle/>
+          <a:p>
+            <a:pPr indent="0" marL="0">
+              <a:buNone/>
+            </a:pPr>
+            <a:r>
+              <a:rPr lang="en-US" sz="1200" dirty="0">
+                <a:solidFill>
+                  <a:srgbClr val="FFFFFF"/>
+                </a:solidFill>
+                <a:latin typeface="Malgun Gothic" pitchFamily="34" charset="0"/>
+                <a:ea typeface="Malgun Gothic" pitchFamily="34" charset="-122"/>
+                <a:cs typeface="Malgun Gothic" pitchFamily="34" charset="-120"/>
+              </a:rPr>
+              <a:t>Outer: R(h) = W3 h + W2 sigma(W1 h)</a:t>
+            </a:r>
+            <a:endParaRPr lang="en-US" sz="1200" dirty="0"/>
+          </a:p>
+        </p:txBody>
+      </p:sp>
+      <p:sp>
+        <p:nvSpPr>
+          <p:cNvPr id="21" name="Text 19"/>
+          <p:cNvSpPr/>
+          <p:nvPr/>
+        </p:nvSpPr>
+        <p:spPr>
+          <a:xfrm>
+            <a:off x="4754880" y="2286000"/>
+            <a:ext cx="3840480" cy="256032"/>
+          </a:xfrm>
+          <a:prstGeom prst="rect">
+            <a:avLst/>
+          </a:prstGeom>
+          <a:noFill/>
+          <a:ln/>
+        </p:spPr>
+        <p:txBody>
+          <a:bodyPr wrap="square" lIns="0" tIns="0" rIns="0" bIns="0" rtlCol="0" anchor="ctr"/>
+          <a:lstStyle/>
+          <a:p>
+            <a:pPr indent="0" marL="0">
+              <a:buNone/>
+            </a:pPr>
+            <a:r>
+              <a:rPr lang="en-US" sz="1200" dirty="0">
+                <a:solidFill>
+                  <a:srgbClr val="FFFFFF"/>
+                </a:solidFill>
+                <a:latin typeface="Malgun Gothic" pitchFamily="34" charset="0"/>
+                <a:ea typeface="Malgun Gothic" pitchFamily="34" charset="-122"/>
+                <a:cs typeface="Malgun Gothic" pitchFamily="34" charset="-120"/>
+              </a:rPr>
+              <a:t>Base LLM은 freeze</a:t>
+            </a:r>
+            <a:endParaRPr lang="en-US" sz="1200" dirty="0"/>
+          </a:p>
+        </p:txBody>
+      </p:sp>
+      <p:sp>
+        <p:nvSpPr>
+          <p:cNvPr id="22" name="Text 20"/>
+          <p:cNvSpPr/>
+          <p:nvPr/>
+        </p:nvSpPr>
+        <p:spPr>
+          <a:xfrm>
+            <a:off x="4754880" y="2560320"/>
+            <a:ext cx="3840480" cy="256032"/>
+          </a:xfrm>
+          <a:prstGeom prst="rect">
+            <a:avLst/>
+          </a:prstGeom>
+          <a:noFill/>
+          <a:ln/>
+        </p:spPr>
+        <p:txBody>
+          <a:bodyPr wrap="square" lIns="0" tIns="0" rIns="0" bIns="0" rtlCol="0" anchor="ctr"/>
+          <a:lstStyle/>
+          <a:p>
+            <a:pPr indent="0" marL="0">
+              <a:buNone/>
+            </a:pPr>
+            <a:r>
+              <a:rPr lang="en-US" sz="1200" dirty="0">
+                <a:solidFill>
+                  <a:srgbClr val="FFFFFF"/>
+                </a:solidFill>
+                <a:latin typeface="Malgun Gothic" pitchFamily="34" charset="0"/>
+                <a:ea typeface="Malgun Gothic" pitchFamily="34" charset="-122"/>
+                <a:cs typeface="Malgun Gothic" pitchFamily="34" charset="-120"/>
+              </a:rPr>
+              <a:t>RecursiveLink만 학습 (~13M, 0.31%)</a:t>
+            </a:r>
+            <a:endParaRPr lang="en-US" sz="1200" dirty="0"/>
+          </a:p>
+        </p:txBody>
+      </p:sp>
+      <p:sp>
+        <p:nvSpPr>
+          <p:cNvPr id="23" name="Text 21"/>
+          <p:cNvSpPr/>
+          <p:nvPr/>
+        </p:nvSpPr>
+        <p:spPr>
+          <a:xfrm>
+            <a:off x="4754880" y="2834640"/>
+            <a:ext cx="3840480" cy="256032"/>
+          </a:xfrm>
+          <a:prstGeom prst="rect">
+            <a:avLst/>
+          </a:prstGeom>
+          <a:noFill/>
+          <a:ln/>
+        </p:spPr>
+        <p:txBody>
+          <a:bodyPr wrap="square" lIns="0" tIns="0" rIns="0" bIns="0" rtlCol="0" anchor="ctr"/>
+          <a:lstStyle/>
+          <a:p>
+            <a:pPr indent="0" marL="0">
+              <a:buNone/>
+            </a:pPr>
+            <a:r>
+              <a:rPr lang="en-US" sz="1200" dirty="0">
+                <a:solidFill>
+                  <a:srgbClr val="FFFFFF"/>
+                </a:solidFill>
+                <a:latin typeface="Malgun Gothic" pitchFamily="34" charset="0"/>
+                <a:ea typeface="Malgun Gothic" pitchFamily="34" charset="-122"/>
+                <a:cs typeface="Malgun Gothic" pitchFamily="34" charset="-120"/>
+              </a:rPr>
+              <a:t>4가지 협업 패턴 모두 지원</a:t>
+            </a:r>
+            <a:endParaRPr lang="en-US" sz="1200" dirty="0"/>
+          </a:p>
+        </p:txBody>
+      </p:sp>
+      <p:sp>
+        <p:nvSpPr>
+          <p:cNvPr id="24" name="Text 22"/>
+          <p:cNvSpPr/>
+          <p:nvPr/>
+        </p:nvSpPr>
+        <p:spPr>
+          <a:xfrm>
+            <a:off x="4754880" y="3383280"/>
+            <a:ext cx="3840480" cy="256032"/>
+          </a:xfrm>
+          <a:prstGeom prst="rect">
+            <a:avLst/>
+          </a:prstGeom>
+          <a:noFill/>
+          <a:ln/>
+        </p:spPr>
+        <p:txBody>
+          <a:bodyPr wrap="square" lIns="0" tIns="0" rIns="0" bIns="0" rtlCol="0" anchor="ctr"/>
+          <a:lstStyle/>
+          <a:p>
+            <a:pPr indent="0" marL="0">
+              <a:buNone/>
+            </a:pPr>
+            <a:r>
+              <a:rPr lang="en-US" sz="1400" b="1" dirty="0">
+                <a:solidFill>
+                  <a:srgbClr val="10B981"/>
+                </a:solidFill>
+                <a:latin typeface="Malgun Gothic" pitchFamily="34" charset="0"/>
+                <a:ea typeface="Malgun Gothic" pitchFamily="34" charset="-122"/>
+                <a:cs typeface="Malgun Gothic" pitchFamily="34" charset="-120"/>
+              </a:rPr>
+              <a:t>-&gt; 1.2-2.4x 가속 + 토큰 34-75% 감소</a:t>
+            </a:r>
+            <a:endParaRPr lang="en-US" sz="1400" dirty="0"/>
+          </a:p>
+        </p:txBody>
+      </p:sp>
+      <p:sp>
+        <p:nvSpPr>
+          <p:cNvPr id="25" name="Text 23"/>
+          <p:cNvSpPr/>
+          <p:nvPr/>
+        </p:nvSpPr>
+        <p:spPr>
+          <a:xfrm>
+            <a:off x="502920" y="4846320"/>
+            <a:ext cx="8229600" cy="228600"/>
+          </a:xfrm>
+          <a:prstGeom prst="rect">
+            <a:avLst/>
+          </a:prstGeom>
+          <a:noFill/>
+          <a:ln/>
+        </p:spPr>
+        <p:txBody>
+          <a:bodyPr wrap="square" lIns="0" tIns="0" rIns="0" bIns="0" rtlCol="0" anchor="ctr"/>
+          <a:lstStyle/>
+          <a:p>
+            <a:pPr indent="0" marL="0">
+              <a:buNone/>
+            </a:pPr>
+            <a:r>
+              <a:rPr lang="en-US" sz="900" i="1" dirty="0">
+                <a:solidFill>
+                  <a:srgbClr val="64748B"/>
+                </a:solidFill>
+                <a:latin typeface="Malgun Gothic" pitchFamily="34" charset="0"/>
+                <a:ea typeface="Malgun Gothic" pitchFamily="34" charset="-122"/>
+                <a:cs typeface="Malgun Gothic" pitchFamily="34" charset="-120"/>
+              </a:rPr>
+              <a:t>출처: arXiv:2604.25917 — Recursive Multi-Agent Systems (UIUC + Stanford + MIT + NVIDIA, 2026-04)</a:t>
+            </a:r>
+            <a:endParaRPr lang="en-US" sz="900" dirty="0"/>
+          </a:p>
+        </p:txBody>
+      </p:sp>
+    </p:spTree>
+  </p:cSld>
+  <p:clrMapOvr>
+    <a:masterClrMapping/>
+  </p:clrMapOvr>
+</p:sld>
+</file>
+
+<file path=ppt/slides/slide13.xml><?xml version="1.0" encoding="utf-8"?>
+<p:sld xmlns:a="http://schemas.openxmlformats.org/drawingml/2006/main" xmlns:p="http://schemas.openxmlformats.org/presentationml/2006/main" xmlns:r="http://schemas.openxmlformats.org/officeDocument/2006/relationships">
+  <p:cSld>
+    <p:spTree>
+      <p:nvGrpSpPr>
+        <p:cNvPr id="1" name=""/>
+        <p:cNvGrpSpPr/>
+        <p:nvPr/>
+      </p:nvGrpSpPr>
+      <p:grpSpPr/>
+      <p:sp>
+        <p:nvSpPr>
+          <p:cNvPr id="2" name="Shape 0"/>
+          <p:cNvSpPr/>
+          <p:nvPr/>
+        </p:nvSpPr>
+        <p:spPr>
+          <a:xfrm>
+            <a:off x="0" y="0"/>
+            <a:ext cx="9144000" cy="54864"/>
+          </a:xfrm>
+          <a:prstGeom prst="rect">
+            <a:avLst/>
+          </a:prstGeom>
+          <a:solidFill>
+            <a:srgbClr val="4FA3E0"/>
+          </a:solidFill>
+          <a:ln w="12700">
+            <a:solidFill>
+              <a:srgbClr val="4FA3E0"/>
+            </a:solidFill>
+            <a:prstDash val="solid"/>
+          </a:ln>
+        </p:spPr>
+        <p:txBody>
+          <a:bodyPr/>
+          <a:p/>
+        </p:txBody>
+      </p:sp>
+      <p:sp>
+        <p:nvSpPr>
+          <p:cNvPr id="3" name="Text 1"/>
+          <p:cNvSpPr/>
+          <p:nvPr/>
+        </p:nvSpPr>
+        <p:spPr>
+          <a:xfrm>
+            <a:off x="502920" y="164592"/>
+            <a:ext cx="8138160" cy="594360"/>
+          </a:xfrm>
+          <a:prstGeom prst="rect">
+            <a:avLst/>
+          </a:prstGeom>
+          <a:noFill/>
+          <a:ln/>
+        </p:spPr>
+        <p:txBody>
+          <a:bodyPr wrap="square" lIns="0" tIns="0" rIns="0" bIns="0" rtlCol="0" anchor="ctr"/>
+          <a:lstStyle/>
+          <a:p>
+            <a:pPr indent="0" marL="0">
+              <a:buNone/>
+            </a:pPr>
+            <a:r>
+              <a:rPr lang="en-US" sz="2800" b="1" dirty="0">
+                <a:solidFill>
+                  <a:srgbClr val="FFFFFF"/>
+                </a:solidFill>
+                <a:latin typeface="Malgun Gothic" pitchFamily="34" charset="0"/>
+                <a:ea typeface="Malgun Gothic" pitchFamily="34" charset="-122"/>
+                <a:cs typeface="Malgun Gothic" pitchFamily="34" charset="-120"/>
+              </a:rPr>
+              <a:t>RecursiveMAS: 9개 벤치마크 결과 + 비용 효율</a:t>
+            </a:r>
+            <a:endParaRPr lang="en-US" sz="2800" dirty="0"/>
+          </a:p>
+        </p:txBody>
+      </p:sp>
+      <p:sp>
+        <p:nvSpPr>
+          <p:cNvPr id="4" name="Shape 2"/>
+          <p:cNvSpPr/>
+          <p:nvPr/>
+        </p:nvSpPr>
+        <p:spPr>
+          <a:xfrm>
+            <a:off x="502920" y="777240"/>
+            <a:ext cx="1097280" cy="41148"/>
+          </a:xfrm>
+          <a:prstGeom prst="rect">
+            <a:avLst/>
+          </a:prstGeom>
+          <a:solidFill>
+            <a:srgbClr val="F97316"/>
+          </a:solidFill>
+          <a:ln w="12700">
+            <a:solidFill>
+              <a:srgbClr val="F97316"/>
+            </a:solidFill>
+            <a:prstDash val="solid"/>
+          </a:ln>
+        </p:spPr>
+      </p:sp>
+      <p:sp>
+        <p:nvSpPr>
+          <p:cNvPr id="5" name="Shape 3"/>
+          <p:cNvSpPr/>
+          <p:nvPr/>
+        </p:nvSpPr>
+        <p:spPr>
+          <a:xfrm>
+            <a:off x="457200" y="960120"/>
+            <a:ext cx="1874520" cy="822960"/>
+          </a:xfrm>
+          <a:prstGeom prst="rect">
+            <a:avLst/>
+          </a:prstGeom>
+          <a:solidFill>
+            <a:srgbClr val="1A2F52"/>
+          </a:solidFill>
+          <a:ln w="12700">
+            <a:solidFill>
+              <a:srgbClr val="4FA3E0"/>
+            </a:solidFill>
+            <a:prstDash val="solid"/>
+          </a:ln>
+        </p:spPr>
+      </p:sp>
+      <p:sp>
+        <p:nvSpPr>
+          <p:cNvPr id="6" name="Text 4"/>
+          <p:cNvSpPr/>
+          <p:nvPr/>
+        </p:nvSpPr>
+        <p:spPr>
+          <a:xfrm>
+            <a:off x="457200" y="960120"/>
+            <a:ext cx="1874520" cy="822960"/>
+          </a:xfrm>
+          <a:prstGeom prst="rect">
+            <a:avLst/>
+          </a:prstGeom>
+          <a:noFill/>
+          <a:ln/>
+        </p:spPr>
+        <p:txBody>
+          <a:bodyPr wrap="square" lIns="50800" tIns="50800" rIns="50800" bIns="50800" rtlCol="0" anchor="ctr"/>
+          <a:lstStyle/>
+          <a:p>
+            <a:pPr algn="ctr" indent="0" marL="0">
+              <a:buNone/>
+            </a:pPr>
+            <a:r>
+              <a:rPr lang="en-US" sz="1000" dirty="0">
+                <a:solidFill>
+                  <a:srgbClr val="FFFFFF"/>
+                </a:solidFill>
+                <a:latin typeface="Malgun Gothic" pitchFamily="34" charset="0"/>
+                <a:ea typeface="Malgun Gothic" pitchFamily="34" charset="-122"/>
+                <a:cs typeface="Malgun Gothic" pitchFamily="34" charset="-120"/>
+              </a:rPr>
+              <a:t>Sequential / Plan-Critic-Solver</a:t>
+            </a:r>
+            <a:endParaRPr lang="en-US" sz="1000" dirty="0"/>
+          </a:p>
+        </p:txBody>
+      </p:sp>
+      <p:sp>
+        <p:nvSpPr>
+          <p:cNvPr id="7" name="Text 5"/>
+          <p:cNvSpPr/>
+          <p:nvPr/>
+        </p:nvSpPr>
+        <p:spPr>
+          <a:xfrm>
+            <a:off x="2331720" y="960120"/>
+            <a:ext cx="228600" cy="822960"/>
+          </a:xfrm>
+          <a:prstGeom prst="rect">
+            <a:avLst/>
+          </a:prstGeom>
+          <a:noFill/>
+          <a:ln/>
+        </p:spPr>
+        <p:txBody>
+          <a:bodyPr wrap="square" lIns="0" tIns="0" rIns="0" bIns="0" rtlCol="0" anchor="ctr"/>
+          <a:lstStyle/>
+          <a:p>
+            <a:pPr algn="ctr" indent="0" marL="0">
+              <a:buNone/>
+            </a:pPr>
+            <a:r>
+              <a:rPr lang="en-US" sz="1400" dirty="0">
+                <a:solidFill>
+                  <a:srgbClr val="4FA3E0"/>
+                </a:solidFill>
+                <a:latin typeface="Arial" pitchFamily="34" charset="0"/>
+                <a:ea typeface="Arial" pitchFamily="34" charset="-122"/>
+                <a:cs typeface="Arial" pitchFamily="34" charset="-120"/>
+              </a:rPr>
+              <a:t>-&gt;</a:t>
+            </a:r>
+            <a:endParaRPr lang="en-US" sz="1400" dirty="0"/>
+          </a:p>
+        </p:txBody>
+      </p:sp>
+      <p:sp>
+        <p:nvSpPr>
+          <p:cNvPr id="8" name="Shape 6"/>
+          <p:cNvSpPr/>
+          <p:nvPr/>
+        </p:nvSpPr>
+        <p:spPr>
+          <a:xfrm>
+            <a:off x="2560320" y="960120"/>
+            <a:ext cx="1874520" cy="822960"/>
+          </a:xfrm>
+          <a:prstGeom prst="rect">
+            <a:avLst/>
+          </a:prstGeom>
+          <a:solidFill>
+            <a:srgbClr val="1A2F52"/>
+          </a:solidFill>
+          <a:ln w="12700">
+            <a:solidFill>
+              <a:srgbClr val="4FA3E0"/>
+            </a:solidFill>
+            <a:prstDash val="solid"/>
+          </a:ln>
+        </p:spPr>
+      </p:sp>
+      <p:sp>
+        <p:nvSpPr>
+          <p:cNvPr id="9" name="Text 7"/>
+          <p:cNvSpPr/>
+          <p:nvPr/>
+        </p:nvSpPr>
+        <p:spPr>
+          <a:xfrm>
+            <a:off x="2560320" y="960120"/>
+            <a:ext cx="1874520" cy="822960"/>
+          </a:xfrm>
+          <a:prstGeom prst="rect">
+            <a:avLst/>
+          </a:prstGeom>
+          <a:noFill/>
+          <a:ln/>
+        </p:spPr>
+        <p:txBody>
+          <a:bodyPr wrap="square" lIns="50800" tIns="50800" rIns="50800" bIns="50800" rtlCol="0" anchor="ctr"/>
+          <a:lstStyle/>
+          <a:p>
+            <a:pPr algn="ctr" indent="0" marL="0">
+              <a:buNone/>
+            </a:pPr>
+            <a:r>
+              <a:rPr lang="en-US" sz="1000" dirty="0">
+                <a:solidFill>
+                  <a:srgbClr val="FFFFFF"/>
+                </a:solidFill>
+                <a:latin typeface="Malgun Gothic" pitchFamily="34" charset="0"/>
+                <a:ea typeface="Malgun Gothic" pitchFamily="34" charset="-122"/>
+                <a:cs typeface="Malgun Gothic" pitchFamily="34" charset="-120"/>
+              </a:rPr>
+              <a:t>Mixture / 도메인 전문가 + Aggregator</a:t>
+            </a:r>
+            <a:endParaRPr lang="en-US" sz="1000" dirty="0"/>
+          </a:p>
+        </p:txBody>
+      </p:sp>
+      <p:sp>
+        <p:nvSpPr>
+          <p:cNvPr id="10" name="Text 8"/>
+          <p:cNvSpPr/>
+          <p:nvPr/>
+        </p:nvSpPr>
+        <p:spPr>
+          <a:xfrm>
+            <a:off x="4434840" y="960120"/>
+            <a:ext cx="228600" cy="822960"/>
+          </a:xfrm>
+          <a:prstGeom prst="rect">
+            <a:avLst/>
+          </a:prstGeom>
+          <a:noFill/>
+          <a:ln/>
+        </p:spPr>
+        <p:txBody>
+          <a:bodyPr wrap="square" lIns="0" tIns="0" rIns="0" bIns="0" rtlCol="0" anchor="ctr"/>
+          <a:lstStyle/>
+          <a:p>
+            <a:pPr algn="ctr" indent="0" marL="0">
+              <a:buNone/>
+            </a:pPr>
+            <a:r>
+              <a:rPr lang="en-US" sz="1400" dirty="0">
+                <a:solidFill>
+                  <a:srgbClr val="4FA3E0"/>
+                </a:solidFill>
+                <a:latin typeface="Arial" pitchFamily="34" charset="0"/>
+                <a:ea typeface="Arial" pitchFamily="34" charset="-122"/>
+                <a:cs typeface="Arial" pitchFamily="34" charset="-120"/>
+              </a:rPr>
+              <a:t>-&gt;</a:t>
+            </a:r>
+            <a:endParaRPr lang="en-US" sz="1400" dirty="0"/>
+          </a:p>
+        </p:txBody>
+      </p:sp>
+      <p:sp>
+        <p:nvSpPr>
+          <p:cNvPr id="11" name="Shape 9"/>
+          <p:cNvSpPr/>
+          <p:nvPr/>
+        </p:nvSpPr>
+        <p:spPr>
+          <a:xfrm>
+            <a:off x="4663440" y="960120"/>
+            <a:ext cx="1874520" cy="822960"/>
+          </a:xfrm>
+          <a:prstGeom prst="rect">
+            <a:avLst/>
+          </a:prstGeom>
+          <a:solidFill>
+            <a:srgbClr val="1A2F52"/>
+          </a:solidFill>
+          <a:ln w="12700">
+            <a:solidFill>
+              <a:srgbClr val="4FA3E0"/>
+            </a:solidFill>
+            <a:prstDash val="solid"/>
+          </a:ln>
+        </p:spPr>
+      </p:sp>
+      <p:sp>
+        <p:nvSpPr>
+          <p:cNvPr id="12" name="Text 10"/>
+          <p:cNvSpPr/>
+          <p:nvPr/>
+        </p:nvSpPr>
+        <p:spPr>
+          <a:xfrm>
+            <a:off x="4663440" y="960120"/>
+            <a:ext cx="1874520" cy="822960"/>
+          </a:xfrm>
+          <a:prstGeom prst="rect">
+            <a:avLst/>
+          </a:prstGeom>
+          <a:noFill/>
+          <a:ln/>
+        </p:spPr>
+        <p:txBody>
+          <a:bodyPr wrap="square" lIns="50800" tIns="50800" rIns="50800" bIns="50800" rtlCol="0" anchor="ctr"/>
+          <a:lstStyle/>
+          <a:p>
+            <a:pPr algn="ctr" indent="0" marL="0">
+              <a:buNone/>
+            </a:pPr>
+            <a:r>
+              <a:rPr lang="en-US" sz="1000" dirty="0">
+                <a:solidFill>
+                  <a:srgbClr val="FFFFFF"/>
+                </a:solidFill>
+                <a:latin typeface="Malgun Gothic" pitchFamily="34" charset="0"/>
+                <a:ea typeface="Malgun Gothic" pitchFamily="34" charset="-122"/>
+                <a:cs typeface="Malgun Gothic" pitchFamily="34" charset="-120"/>
+              </a:rPr>
+              <a:t>Distillation / Expert ↔ Learner</a:t>
+            </a:r>
+            <a:endParaRPr lang="en-US" sz="1000" dirty="0"/>
+          </a:p>
+        </p:txBody>
+      </p:sp>
+      <p:sp>
+        <p:nvSpPr>
+          <p:cNvPr id="13" name="Text 11"/>
+          <p:cNvSpPr/>
+          <p:nvPr/>
+        </p:nvSpPr>
+        <p:spPr>
+          <a:xfrm>
+            <a:off x="6537960" y="960120"/>
+            <a:ext cx="228600" cy="822960"/>
+          </a:xfrm>
+          <a:prstGeom prst="rect">
+            <a:avLst/>
+          </a:prstGeom>
+          <a:noFill/>
+          <a:ln/>
+        </p:spPr>
+        <p:txBody>
+          <a:bodyPr wrap="square" lIns="0" tIns="0" rIns="0" bIns="0" rtlCol="0" anchor="ctr"/>
+          <a:lstStyle/>
+          <a:p>
+            <a:pPr algn="ctr" indent="0" marL="0">
+              <a:buNone/>
+            </a:pPr>
+            <a:r>
+              <a:rPr lang="en-US" sz="1400" dirty="0">
+                <a:solidFill>
+                  <a:srgbClr val="4FA3E0"/>
+                </a:solidFill>
+                <a:latin typeface="Arial" pitchFamily="34" charset="0"/>
+                <a:ea typeface="Arial" pitchFamily="34" charset="-122"/>
+                <a:cs typeface="Arial" pitchFamily="34" charset="-120"/>
+              </a:rPr>
+              <a:t>-&gt;</a:t>
+            </a:r>
+            <a:endParaRPr lang="en-US" sz="1400" dirty="0"/>
+          </a:p>
+        </p:txBody>
+      </p:sp>
+      <p:sp>
+        <p:nvSpPr>
+          <p:cNvPr id="14" name="Shape 12"/>
+          <p:cNvSpPr/>
+          <p:nvPr/>
+        </p:nvSpPr>
+        <p:spPr>
+          <a:xfrm>
+            <a:off x="6766560" y="960120"/>
+            <a:ext cx="1874520" cy="822960"/>
+          </a:xfrm>
+          <a:prstGeom prst="rect">
+            <a:avLst/>
+          </a:prstGeom>
+          <a:solidFill>
+            <a:srgbClr val="F97316"/>
+          </a:solidFill>
+          <a:ln w="25400">
+            <a:solidFill>
+              <a:srgbClr val="F97316"/>
+            </a:solidFill>
+            <a:prstDash val="solid"/>
+          </a:ln>
+        </p:spPr>
+      </p:sp>
+      <p:sp>
+        <p:nvSpPr>
+          <p:cNvPr id="15" name="Text 13"/>
+          <p:cNvSpPr/>
+          <p:nvPr/>
+        </p:nvSpPr>
+        <p:spPr>
+          <a:xfrm>
+            <a:off x="6766560" y="960120"/>
+            <a:ext cx="1874520" cy="822960"/>
+          </a:xfrm>
+          <a:prstGeom prst="rect">
+            <a:avLst/>
+          </a:prstGeom>
+          <a:noFill/>
+          <a:ln/>
+        </p:spPr>
+        <p:txBody>
+          <a:bodyPr wrap="square" lIns="50800" tIns="50800" rIns="50800" bIns="50800" rtlCol="0" anchor="ctr"/>
+          <a:lstStyle/>
+          <a:p>
+            <a:pPr algn="ctr" indent="0" marL="0">
+              <a:buNone/>
+            </a:pPr>
+            <a:r>
+              <a:rPr lang="en-US" sz="1000" dirty="0">
+                <a:solidFill>
+                  <a:srgbClr val="FFFFFF"/>
+                </a:solidFill>
+                <a:latin typeface="Malgun Gothic" pitchFamily="34" charset="0"/>
+                <a:ea typeface="Malgun Gothic" pitchFamily="34" charset="-122"/>
+                <a:cs typeface="Malgun Gothic" pitchFamily="34" charset="-120"/>
+              </a:rPr>
+              <a:t>Deliberation / Reflector + Tool</a:t>
+            </a:r>
+            <a:endParaRPr lang="en-US" sz="1000" dirty="0"/>
+          </a:p>
+        </p:txBody>
+      </p:sp>
+      <p:graphicFrame>
+        <p:nvGraphicFramePr>
+          <p:cNvPr id="7" name="Table 0"/>
+          <p:cNvGraphicFramePr>
+            <a:graphicFrameLocks noGrp="1"/>
+          </p:cNvGraphicFramePr>
+          <p:nvPr>
+            <p:extLst>
+              <p:ext uri="{D42A27DB-BD31-4B8C-83A1-F6EECF244321}">
+                <p14:modId xmlns:p14="http://schemas.microsoft.com/office/powerpoint/2010/main" val="1579011935"/>
+              </p:ext>
+            </p:extLst>
+          </p:nvPr>
+        </p:nvGraphicFramePr>
+        <p:xfrm>
+          <a:off x="457200" y="1920240"/>
+          <a:ext cx="8229600" cy="1645920"/>
+        </p:xfrm>
+        <a:graphic>
+          <a:graphicData uri="http://schemas.openxmlformats.org/drawingml/2006/table">
+            <a:tbl>
+              <a:tblPr/>
+              <a:tblGrid>
+                <a:gridCol w="2286000"/>
+                <a:gridCol w="1828800"/>
+                <a:gridCol w="2286000"/>
+                <a:gridCol w="1828800"/>
+              </a:tblGrid>
+              <a:tr h="411480">
+                <a:tc>
+                  <a:txBody>
+                    <a:bodyPr/>
+                    <a:lstStyle/>
+                    <a:p>
+                      <a:pPr algn="ctr" indent="0" marL="0">
+                        <a:buNone/>
+                      </a:pPr>
+                      <a:r>
+                        <a:rPr lang="en-US" sz="1300" b="1" dirty="0">
+                          <a:solidFill>
+                            <a:srgbClr val="FFFFFF"/>
+                          </a:solidFill>
+                          <a:latin typeface="Malgun Gothic" pitchFamily="34" charset="0"/>
+                          <a:ea typeface="Malgun Gothic" pitchFamily="34" charset="-122"/>
+                          <a:cs typeface="Malgun Gothic" pitchFamily="34" charset="-120"/>
+                        </a:rPr>
+                        <a:t>벤치마크/설정</a:t>
+                      </a:r>
+                      <a:endParaRPr lang="en-US" sz="1300" dirty="0">
+                        <a:latin typeface="Malgun Gothic" charset="0"/>
+                        <a:ea typeface="Malgun Gothic" charset="0"/>
+                        <a:cs typeface="Malgun Gothic" charset="0"/>
+                      </a:endParaRPr>
+                    </a:p>
+                  </a:txBody>
+                  <a:tcPr marL="91440" marR="91440" marT="45720" marB="45720">
+                    <a:lnL w="12700" cap="flat" cmpd="sng" algn="ctr">
+                      <a:solidFill>
+                        <a:srgbClr val="2A3F6A"/>
+                      </a:solidFill>
+                      <a:prstDash val="solid"/>
+                      <a:round/>
+                      <a:headEnd type="none" w="med" len="med"/>
+                      <a:tailEnd type="none" w="med" len="med"/>
+                    </a:lnL>
+                    <a:lnR w="12700" cap="flat" cmpd="sng" algn="ctr">
+                      <a:solidFill>
+                        <a:srgbClr val="2A3F6A"/>
+                      </a:solidFill>
+                      <a:prstDash val="solid"/>
+                      <a:round/>
+                      <a:headEnd type="none" w="med" len="med"/>
+                      <a:tailEnd type="none" w="med" len="med"/>
+                    </a:lnR>
+                    <a:lnT w="12700" cap="flat" cmpd="sng" algn="ctr">
+                      <a:solidFill>
+                        <a:srgbClr val="2A3F6A"/>
+                      </a:solidFill>
+                      <a:prstDash val="solid"/>
+                      <a:round/>
+                      <a:headEnd type="none" w="med" len="med"/>
+                      <a:tailEnd type="none" w="med" len="med"/>
+                    </a:lnT>
+                    <a:lnB w="12700" cap="flat" cmpd="sng" algn="ctr">
+                      <a:solidFill>
+                        <a:srgbClr val="2A3F6A"/>
+                      </a:solidFill>
+                      <a:prstDash val="solid"/>
+                      <a:round/>
+                      <a:headEnd type="none" w="med" len="med"/>
+                      <a:tailEnd type="none" w="med" len="med"/>
+                    </a:lnB>
+                    <a:solidFill>
+                      <a:srgbClr val="1A2F52"/>
+                    </a:solidFill>
+                  </a:tcPr>
+                </a:tc>
+                <a:tc>
+                  <a:txBody>
+                    <a:bodyPr/>
+                    <a:lstStyle/>
+                    <a:p>
+                      <a:pPr algn="ctr" indent="0" marL="0">
+                        <a:buNone/>
+                      </a:pPr>
+                      <a:r>
+                        <a:rPr lang="en-US" sz="1300" b="1" dirty="0">
+                          <a:solidFill>
+                            <a:srgbClr val="FFFFFF"/>
+                          </a:solidFill>
+                          <a:latin typeface="Malgun Gothic" pitchFamily="34" charset="0"/>
+                          <a:ea typeface="Malgun Gothic" pitchFamily="34" charset="-122"/>
+                          <a:cs typeface="Malgun Gothic" pitchFamily="34" charset="-120"/>
+                        </a:rPr>
+                        <a:t>TextMAS</a:t>
+                      </a:r>
+                      <a:endParaRPr lang="en-US" sz="1300" dirty="0">
+                        <a:latin typeface="Malgun Gothic" charset="0"/>
+                        <a:ea typeface="Malgun Gothic" charset="0"/>
+                        <a:cs typeface="Malgun Gothic" charset="0"/>
+                      </a:endParaRPr>
+                    </a:p>
+                  </a:txBody>
+                  <a:tcPr marL="91440" marR="91440" marT="45720" marB="45720">
+                    <a:lnL w="12700" cap="flat" cmpd="sng" algn="ctr">
+                      <a:solidFill>
+                        <a:srgbClr val="2A3F6A"/>
+                      </a:solidFill>
+                      <a:prstDash val="solid"/>
+                      <a:round/>
+                      <a:headEnd type="none" w="med" len="med"/>
+                      <a:tailEnd type="none" w="med" len="med"/>
+                    </a:lnL>
+                    <a:lnR w="12700" cap="flat" cmpd="sng" algn="ctr">
+                      <a:solidFill>
+                        <a:srgbClr val="2A3F6A"/>
+                      </a:solidFill>
+                      <a:prstDash val="solid"/>
+                      <a:round/>
+                      <a:headEnd type="none" w="med" len="med"/>
+                      <a:tailEnd type="none" w="med" len="med"/>
+                    </a:lnR>
+                    <a:lnT w="12700" cap="flat" cmpd="sng" algn="ctr">
+                      <a:solidFill>
+                        <a:srgbClr val="2A3F6A"/>
+                      </a:solidFill>
+                      <a:prstDash val="solid"/>
+                      <a:round/>
+                      <a:headEnd type="none" w="med" len="med"/>
+                      <a:tailEnd type="none" w="med" len="med"/>
+                    </a:lnT>
+                    <a:lnB w="12700" cap="flat" cmpd="sng" algn="ctr">
+                      <a:solidFill>
+                        <a:srgbClr val="2A3F6A"/>
+                      </a:solidFill>
+                      <a:prstDash val="solid"/>
+                      <a:round/>
+                      <a:headEnd type="none" w="med" len="med"/>
+                      <a:tailEnd type="none" w="med" len="med"/>
+                    </a:lnB>
+                    <a:solidFill>
+                      <a:srgbClr val="1A2F52"/>
+                    </a:solidFill>
+                  </a:tcPr>
+                </a:tc>
+                <a:tc>
+                  <a:txBody>
+                    <a:bodyPr/>
+                    <a:lstStyle/>
+                    <a:p>
+                      <a:pPr algn="ctr" indent="0" marL="0">
+                        <a:buNone/>
+                      </a:pPr>
+                      <a:r>
+                        <a:rPr lang="en-US" sz="1300" b="1" dirty="0">
+                          <a:solidFill>
+                            <a:srgbClr val="FFFFFF"/>
+                          </a:solidFill>
+                          <a:latin typeface="Malgun Gothic" pitchFamily="34" charset="0"/>
+                          <a:ea typeface="Malgun Gothic" pitchFamily="34" charset="-122"/>
+                          <a:cs typeface="Malgun Gothic" pitchFamily="34" charset="-120"/>
+                        </a:rPr>
+                        <a:t>RecursiveMAS</a:t>
+                      </a:r>
+                      <a:endParaRPr lang="en-US" sz="1300" dirty="0">
+                        <a:latin typeface="Malgun Gothic" charset="0"/>
+                        <a:ea typeface="Malgun Gothic" charset="0"/>
+                        <a:cs typeface="Malgun Gothic" charset="0"/>
+                      </a:endParaRPr>
+                    </a:p>
+                  </a:txBody>
+                  <a:tcPr marL="91440" marR="91440" marT="45720" marB="45720">
+                    <a:lnL w="12700" cap="flat" cmpd="sng" algn="ctr">
+                      <a:solidFill>
+                        <a:srgbClr val="2A3F6A"/>
+                      </a:solidFill>
+                      <a:prstDash val="solid"/>
+                      <a:round/>
+                      <a:headEnd type="none" w="med" len="med"/>
+                      <a:tailEnd type="none" w="med" len="med"/>
+                    </a:lnL>
+                    <a:lnR w="12700" cap="flat" cmpd="sng" algn="ctr">
+                      <a:solidFill>
+                        <a:srgbClr val="2A3F6A"/>
+                      </a:solidFill>
+                      <a:prstDash val="solid"/>
+                      <a:round/>
+                      <a:headEnd type="none" w="med" len="med"/>
+                      <a:tailEnd type="none" w="med" len="med"/>
+                    </a:lnR>
+                    <a:lnT w="12700" cap="flat" cmpd="sng" algn="ctr">
+                      <a:solidFill>
+                        <a:srgbClr val="2A3F6A"/>
+                      </a:solidFill>
+                      <a:prstDash val="solid"/>
+                      <a:round/>
+                      <a:headEnd type="none" w="med" len="med"/>
+                      <a:tailEnd type="none" w="med" len="med"/>
+                    </a:lnT>
+                    <a:lnB w="12700" cap="flat" cmpd="sng" algn="ctr">
+                      <a:solidFill>
+                        <a:srgbClr val="2A3F6A"/>
+                      </a:solidFill>
+                      <a:prstDash val="solid"/>
+                      <a:round/>
+                      <a:headEnd type="none" w="med" len="med"/>
+                      <a:tailEnd type="none" w="med" len="med"/>
+                    </a:lnB>
+                    <a:solidFill>
+                      <a:srgbClr val="1A2F52"/>
+                    </a:solidFill>
+                  </a:tcPr>
+                </a:tc>
+                <a:tc>
+                  <a:txBody>
+                    <a:bodyPr/>
+                    <a:lstStyle/>
+                    <a:p>
+                      <a:pPr algn="ctr" indent="0" marL="0">
+                        <a:buNone/>
+                      </a:pPr>
+                      <a:r>
+                        <a:rPr lang="en-US" sz="1300" b="1" dirty="0">
+                          <a:solidFill>
+                            <a:srgbClr val="FFFFFF"/>
+                          </a:solidFill>
+                          <a:latin typeface="Malgun Gothic" pitchFamily="34" charset="0"/>
+                          <a:ea typeface="Malgun Gothic" pitchFamily="34" charset="-122"/>
+                          <a:cs typeface="Malgun Gothic" pitchFamily="34" charset="-120"/>
+                        </a:rPr>
+                        <a:t>변화</a:t>
+                      </a:r>
+                      <a:endParaRPr lang="en-US" sz="1300" dirty="0">
+                        <a:latin typeface="Malgun Gothic" charset="0"/>
+                        <a:ea typeface="Malgun Gothic" charset="0"/>
+                        <a:cs typeface="Malgun Gothic" charset="0"/>
+                      </a:endParaRPr>
+                    </a:p>
+                  </a:txBody>
+                  <a:tcPr marL="91440" marR="91440" marT="45720" marB="45720">
+                    <a:lnL w="12700" cap="flat" cmpd="sng" algn="ctr">
+                      <a:solidFill>
+                        <a:srgbClr val="2A3F6A"/>
+                      </a:solidFill>
+                      <a:prstDash val="solid"/>
+                      <a:round/>
+                      <a:headEnd type="none" w="med" len="med"/>
+                      <a:tailEnd type="none" w="med" len="med"/>
+                    </a:lnL>
+                    <a:lnR w="12700" cap="flat" cmpd="sng" algn="ctr">
+                      <a:solidFill>
+                        <a:srgbClr val="2A3F6A"/>
+                      </a:solidFill>
+                      <a:prstDash val="solid"/>
+                      <a:round/>
+                      <a:headEnd type="none" w="med" len="med"/>
+                      <a:tailEnd type="none" w="med" len="med"/>
+                    </a:lnR>
+                    <a:lnT w="12700" cap="flat" cmpd="sng" algn="ctr">
+                      <a:solidFill>
+                        <a:srgbClr val="2A3F6A"/>
+                      </a:solidFill>
+                      <a:prstDash val="solid"/>
+                      <a:round/>
+                      <a:headEnd type="none" w="med" len="med"/>
+                      <a:tailEnd type="none" w="med" len="med"/>
+                    </a:lnT>
+                    <a:lnB w="12700" cap="flat" cmpd="sng" algn="ctr">
+                      <a:solidFill>
+                        <a:srgbClr val="2A3F6A"/>
+                      </a:solidFill>
+                      <a:prstDash val="solid"/>
+                      <a:round/>
+                      <a:headEnd type="none" w="med" len="med"/>
+                      <a:tailEnd type="none" w="med" len="med"/>
+                    </a:lnB>
+                    <a:solidFill>
+                      <a:srgbClr val="1A2F52"/>
+                    </a:solidFill>
+                  </a:tcPr>
+                </a:tc>
+              </a:tr>
+              <a:tr h="411480">
+                <a:tc>
+                  <a:txBody>
+                    <a:bodyPr/>
+                    <a:lstStyle/>
+                    <a:p>
+                      <a:pPr algn="l" indent="0" marL="0">
+                        <a:buNone/>
+                      </a:pPr>
+                      <a:r>
+                        <a:rPr lang="en-US" sz="1300" dirty="0">
+                          <a:solidFill>
+                            <a:srgbClr val="FFFFFF"/>
+                          </a:solidFill>
+                          <a:latin typeface="Malgun Gothic" pitchFamily="34" charset="0"/>
+                          <a:ea typeface="Malgun Gothic" pitchFamily="34" charset="-122"/>
+                          <a:cs typeface="Malgun Gothic" pitchFamily="34" charset="-120"/>
+                        </a:rPr>
+                        <a:t>MATH500 Scaled (acc)</a:t>
+                      </a:r>
+                      <a:endParaRPr lang="en-US" sz="1300" dirty="0">
+                        <a:latin typeface="Malgun Gothic" charset="0"/>
+                        <a:ea typeface="Malgun Gothic" charset="0"/>
+                        <a:cs typeface="Malgun Gothic" charset="0"/>
+                      </a:endParaRPr>
+                    </a:p>
+                  </a:txBody>
+                  <a:tcPr marL="91440" marR="91440" marT="45720" marB="45720">
+                    <a:lnL w="12700" cap="flat" cmpd="sng" algn="ctr">
+                      <a:solidFill>
+                        <a:srgbClr val="2A3F6A"/>
+                      </a:solidFill>
+                      <a:prstDash val="solid"/>
+                      <a:round/>
+                      <a:headEnd type="none" w="med" len="med"/>
+                      <a:tailEnd type="none" w="med" len="med"/>
+                    </a:lnL>
+                    <a:lnR w="12700" cap="flat" cmpd="sng" algn="ctr">
+                      <a:solidFill>
+                        <a:srgbClr val="2A3F6A"/>
+                      </a:solidFill>
+                      <a:prstDash val="solid"/>
+                      <a:round/>
+                      <a:headEnd type="none" w="med" len="med"/>
+                      <a:tailEnd type="none" w="med" len="med"/>
+                    </a:lnR>
+                    <a:lnT w="12700" cap="flat" cmpd="sng" algn="ctr">
+                      <a:solidFill>
+                        <a:srgbClr val="2A3F6A"/>
+                      </a:solidFill>
+                      <a:prstDash val="solid"/>
+                      <a:round/>
+                      <a:headEnd type="none" w="med" len="med"/>
+                      <a:tailEnd type="none" w="med" len="med"/>
+                    </a:lnT>
+                    <a:lnB w="12700" cap="flat" cmpd="sng" algn="ctr">
+                      <a:solidFill>
+                        <a:srgbClr val="2A3F6A"/>
+                      </a:solidFill>
+                      <a:prstDash val="solid"/>
+                      <a:round/>
+                      <a:headEnd type="none" w="med" len="med"/>
+                      <a:tailEnd type="none" w="med" len="med"/>
+                    </a:lnB>
+                    <a:solidFill>
+                      <a:srgbClr val="1A2F52"/>
+                    </a:solidFill>
+                  </a:tcPr>
+                </a:tc>
+                <a:tc>
+                  <a:txBody>
+                    <a:bodyPr/>
+                    <a:lstStyle/>
+                    <a:p>
+                      <a:pPr algn="ctr" indent="0" marL="0">
+                        <a:buNone/>
+                      </a:pPr>
+                      <a:r>
+                        <a:rPr lang="en-US" sz="1300" dirty="0">
+                          <a:solidFill>
+                            <a:srgbClr val="FFFFFF"/>
+                          </a:solidFill>
+                          <a:latin typeface="Malgun Gothic" pitchFamily="34" charset="0"/>
+                          <a:ea typeface="Malgun Gothic" pitchFamily="34" charset="-122"/>
+                          <a:cs typeface="Malgun Gothic" pitchFamily="34" charset="-120"/>
+                        </a:rPr>
+                        <a:t>85.8%</a:t>
+                      </a:r>
+                      <a:endParaRPr lang="en-US" sz="1300" dirty="0">
+                        <a:latin typeface="Malgun Gothic" charset="0"/>
+                        <a:ea typeface="Malgun Gothic" charset="0"/>
+                        <a:cs typeface="Malgun Gothic" charset="0"/>
+                      </a:endParaRPr>
+                    </a:p>
+                  </a:txBody>
+                  <a:tcPr marL="91440" marR="91440" marT="45720" marB="45720">
+                    <a:lnL w="12700" cap="flat" cmpd="sng" algn="ctr">
+                      <a:solidFill>
+                        <a:srgbClr val="2A3F6A"/>
+                      </a:solidFill>
+                      <a:prstDash val="solid"/>
+                      <a:round/>
+                      <a:headEnd type="none" w="med" len="med"/>
+                      <a:tailEnd type="none" w="med" len="med"/>
+                    </a:lnL>
+                    <a:lnR w="12700" cap="flat" cmpd="sng" algn="ctr">
+                      <a:solidFill>
+                        <a:srgbClr val="2A3F6A"/>
+                      </a:solidFill>
+                      <a:prstDash val="solid"/>
+                      <a:round/>
+                      <a:headEnd type="none" w="med" len="med"/>
+                      <a:tailEnd type="none" w="med" len="med"/>
+                    </a:lnR>
+                    <a:lnT w="12700" cap="flat" cmpd="sng" algn="ctr">
+                      <a:solidFill>
+                        <a:srgbClr val="2A3F6A"/>
+                      </a:solidFill>
+                      <a:prstDash val="solid"/>
+                      <a:round/>
+                      <a:headEnd type="none" w="med" len="med"/>
+                      <a:tailEnd type="none" w="med" len="med"/>
+                    </a:lnT>
+                    <a:lnB w="12700" cap="flat" cmpd="sng" algn="ctr">
+                      <a:solidFill>
+                        <a:srgbClr val="2A3F6A"/>
+                      </a:solidFill>
+                      <a:prstDash val="solid"/>
+                      <a:round/>
+                      <a:headEnd type="none" w="med" len="med"/>
+                      <a:tailEnd type="none" w="med" len="med"/>
+                    </a:lnB>
+                    <a:solidFill>
+                      <a:srgbClr val="1A2F52"/>
+                    </a:solidFill>
+                  </a:tcPr>
+                </a:tc>
+                <a:tc>
+                  <a:txBody>
+                    <a:bodyPr/>
+                    <a:lstStyle/>
+                    <a:p>
+                      <a:pPr algn="ctr" indent="0" marL="0">
+                        <a:buNone/>
+                      </a:pPr>
+                      <a:r>
+                        <a:rPr lang="en-US" sz="1300" dirty="0">
+                          <a:solidFill>
+                            <a:srgbClr val="FFFFFF"/>
+                          </a:solidFill>
+                          <a:latin typeface="Malgun Gothic" pitchFamily="34" charset="0"/>
+                          <a:ea typeface="Malgun Gothic" pitchFamily="34" charset="-122"/>
+                          <a:cs typeface="Malgun Gothic" pitchFamily="34" charset="-120"/>
+                        </a:rPr>
+                        <a:t>88.0%</a:t>
+                      </a:r>
+                      <a:endParaRPr lang="en-US" sz="1300" dirty="0">
+                        <a:latin typeface="Malgun Gothic" charset="0"/>
+                        <a:ea typeface="Malgun Gothic" charset="0"/>
+                        <a:cs typeface="Malgun Gothic" charset="0"/>
+                      </a:endParaRPr>
+                    </a:p>
+                  </a:txBody>
+                  <a:tcPr marL="91440" marR="91440" marT="45720" marB="45720">
+                    <a:lnL w="12700" cap="flat" cmpd="sng" algn="ctr">
+                      <a:solidFill>
+                        <a:srgbClr val="2A3F6A"/>
+                      </a:solidFill>
+                      <a:prstDash val="solid"/>
+                      <a:round/>
+                      <a:headEnd type="none" w="med" len="med"/>
+                      <a:tailEnd type="none" w="med" len="med"/>
+                    </a:lnL>
+                    <a:lnR w="12700" cap="flat" cmpd="sng" algn="ctr">
+                      <a:solidFill>
+                        <a:srgbClr val="2A3F6A"/>
+                      </a:solidFill>
+                      <a:prstDash val="solid"/>
+                      <a:round/>
+                      <a:headEnd type="none" w="med" len="med"/>
+                      <a:tailEnd type="none" w="med" len="med"/>
+                    </a:lnR>
+                    <a:lnT w="12700" cap="flat" cmpd="sng" algn="ctr">
+                      <a:solidFill>
+                        <a:srgbClr val="2A3F6A"/>
+                      </a:solidFill>
+                      <a:prstDash val="solid"/>
+                      <a:round/>
+                      <a:headEnd type="none" w="med" len="med"/>
+                      <a:tailEnd type="none" w="med" len="med"/>
+                    </a:lnT>
+                    <a:lnB w="12700" cap="flat" cmpd="sng" algn="ctr">
+                      <a:solidFill>
+                        <a:srgbClr val="2A3F6A"/>
+                      </a:solidFill>
+                      <a:prstDash val="solid"/>
+                      <a:round/>
+                      <a:headEnd type="none" w="med" len="med"/>
+                      <a:tailEnd type="none" w="med" len="med"/>
+                    </a:lnB>
+                    <a:solidFill>
+                      <a:srgbClr val="1A2F52"/>
+                    </a:solidFill>
+                  </a:tcPr>
+                </a:tc>
+                <a:tc>
+                  <a:txBody>
+                    <a:bodyPr/>
+                    <a:lstStyle/>
+                    <a:p>
+                      <a:pPr algn="ctr" indent="0" marL="0">
+                        <a:buNone/>
+                      </a:pPr>
+                      <a:r>
+                        <a:rPr lang="en-US" sz="1300" b="1" dirty="0">
+                          <a:solidFill>
+                            <a:srgbClr val="FBBF24"/>
+                          </a:solidFill>
+                          <a:latin typeface="Malgun Gothic" pitchFamily="34" charset="0"/>
+                          <a:ea typeface="Malgun Gothic" pitchFamily="34" charset="-122"/>
+                          <a:cs typeface="Malgun Gothic" pitchFamily="34" charset="-120"/>
+                        </a:rPr>
+                        <a:t>+2.2%p</a:t>
+                      </a:r>
+                      <a:endParaRPr lang="en-US" sz="1300" dirty="0">
+                        <a:latin typeface="Malgun Gothic" charset="0"/>
+                        <a:ea typeface="Malgun Gothic" charset="0"/>
+                        <a:cs typeface="Malgun Gothic" charset="0"/>
+                      </a:endParaRPr>
+                    </a:p>
+                  </a:txBody>
+                  <a:tcPr marL="91440" marR="91440" marT="45720" marB="45720">
+                    <a:lnL w="12700" cap="flat" cmpd="sng" algn="ctr">
+                      <a:solidFill>
+                        <a:srgbClr val="2A3F6A"/>
+                      </a:solidFill>
+                      <a:prstDash val="solid"/>
+                      <a:round/>
+                      <a:headEnd type="none" w="med" len="med"/>
+                      <a:tailEnd type="none" w="med" len="med"/>
+                    </a:lnL>
+                    <a:lnR w="12700" cap="flat" cmpd="sng" algn="ctr">
+                      <a:solidFill>
+                        <a:srgbClr val="2A3F6A"/>
+                      </a:solidFill>
+                      <a:prstDash val="solid"/>
+                      <a:round/>
+                      <a:headEnd type="none" w="med" len="med"/>
+                      <a:tailEnd type="none" w="med" len="med"/>
+                    </a:lnR>
+                    <a:lnT w="12700" cap="flat" cmpd="sng" algn="ctr">
+                      <a:solidFill>
+                        <a:srgbClr val="2A3F6A"/>
+                      </a:solidFill>
+                      <a:prstDash val="solid"/>
+                      <a:round/>
+                      <a:headEnd type="none" w="med" len="med"/>
+                      <a:tailEnd type="none" w="med" len="med"/>
+                    </a:lnT>
+                    <a:lnB w="12700" cap="flat" cmpd="sng" algn="ctr">
+                      <a:solidFill>
+                        <a:srgbClr val="2A3F6A"/>
+                      </a:solidFill>
+                      <a:prstDash val="solid"/>
+                      <a:round/>
+                      <a:headEnd type="none" w="med" len="med"/>
+                      <a:tailEnd type="none" w="med" len="med"/>
+                    </a:lnB>
+                    <a:solidFill>
+                      <a:srgbClr val="1A2F52"/>
+                    </a:solidFill>
+                  </a:tcPr>
+                </a:tc>
+              </a:tr>
+              <a:tr h="411480">
+                <a:tc>
+                  <a:txBody>
+                    <a:bodyPr/>
+                    <a:lstStyle/>
+                    <a:p>
+                      <a:pPr algn="l" indent="0" marL="0">
+                        <a:buNone/>
+                      </a:pPr>
+                      <a:r>
+                        <a:rPr lang="en-US" sz="1300" dirty="0">
+                          <a:solidFill>
+                            <a:srgbClr val="FFFFFF"/>
+                          </a:solidFill>
+                          <a:latin typeface="Malgun Gothic" pitchFamily="34" charset="0"/>
+                          <a:ea typeface="Malgun Gothic" pitchFamily="34" charset="-122"/>
+                          <a:cs typeface="Malgun Gothic" pitchFamily="34" charset="-120"/>
+                        </a:rPr>
+                        <a:t>MATH500 Scaled (time)</a:t>
+                      </a:r>
+                      <a:endParaRPr lang="en-US" sz="1300" dirty="0">
+                        <a:latin typeface="Malgun Gothic" charset="0"/>
+                        <a:ea typeface="Malgun Gothic" charset="0"/>
+                        <a:cs typeface="Malgun Gothic" charset="0"/>
+                      </a:endParaRPr>
+                    </a:p>
+                  </a:txBody>
+                  <a:tcPr marL="91440" marR="91440" marT="45720" marB="45720">
+                    <a:lnL w="12700" cap="flat" cmpd="sng" algn="ctr">
+                      <a:solidFill>
+                        <a:srgbClr val="2A3F6A"/>
+                      </a:solidFill>
+                      <a:prstDash val="solid"/>
+                      <a:round/>
+                      <a:headEnd type="none" w="med" len="med"/>
+                      <a:tailEnd type="none" w="med" len="med"/>
+                    </a:lnL>
+                    <a:lnR w="12700" cap="flat" cmpd="sng" algn="ctr">
+                      <a:solidFill>
+                        <a:srgbClr val="2A3F6A"/>
+                      </a:solidFill>
+                      <a:prstDash val="solid"/>
+                      <a:round/>
+                      <a:headEnd type="none" w="med" len="med"/>
+                      <a:tailEnd type="none" w="med" len="med"/>
+                    </a:lnR>
+                    <a:lnT w="12700" cap="flat" cmpd="sng" algn="ctr">
+                      <a:solidFill>
+                        <a:srgbClr val="2A3F6A"/>
+                      </a:solidFill>
+                      <a:prstDash val="solid"/>
+                      <a:round/>
+                      <a:headEnd type="none" w="med" len="med"/>
+                      <a:tailEnd type="none" w="med" len="med"/>
+                    </a:lnT>
+                    <a:lnB w="12700" cap="flat" cmpd="sng" algn="ctr">
+                      <a:solidFill>
+                        <a:srgbClr val="2A3F6A"/>
+                      </a:solidFill>
+                      <a:prstDash val="solid"/>
+                      <a:round/>
+                      <a:headEnd type="none" w="med" len="med"/>
+                      <a:tailEnd type="none" w="med" len="med"/>
+                    </a:lnB>
+                    <a:solidFill>
+                      <a:srgbClr val="152440"/>
+                    </a:solidFill>
+                  </a:tcPr>
+                </a:tc>
+                <a:tc>
+                  <a:txBody>
+                    <a:bodyPr/>
+                    <a:lstStyle/>
+                    <a:p>
+                      <a:pPr algn="ctr" indent="0" marL="0">
+                        <a:buNone/>
+                      </a:pPr>
+                      <a:r>
+                        <a:rPr lang="en-US" sz="1300" dirty="0">
+                          <a:solidFill>
+                            <a:srgbClr val="FFFFFF"/>
+                          </a:solidFill>
+                          <a:latin typeface="Malgun Gothic" pitchFamily="34" charset="0"/>
+                          <a:ea typeface="Malgun Gothic" pitchFamily="34" charset="-122"/>
+                          <a:cs typeface="Malgun Gothic" pitchFamily="34" charset="-120"/>
+                        </a:rPr>
+                        <a:t>6010s</a:t>
+                      </a:r>
+                      <a:endParaRPr lang="en-US" sz="1300" dirty="0">
+                        <a:latin typeface="Malgun Gothic" charset="0"/>
+                        <a:ea typeface="Malgun Gothic" charset="0"/>
+                        <a:cs typeface="Malgun Gothic" charset="0"/>
+                      </a:endParaRPr>
+                    </a:p>
+                  </a:txBody>
+                  <a:tcPr marL="91440" marR="91440" marT="45720" marB="45720">
+                    <a:lnL w="12700" cap="flat" cmpd="sng" algn="ctr">
+                      <a:solidFill>
+                        <a:srgbClr val="2A3F6A"/>
+                      </a:solidFill>
+                      <a:prstDash val="solid"/>
+                      <a:round/>
+                      <a:headEnd type="none" w="med" len="med"/>
+                      <a:tailEnd type="none" w="med" len="med"/>
+                    </a:lnL>
+                    <a:lnR w="12700" cap="flat" cmpd="sng" algn="ctr">
+                      <a:solidFill>
+                        <a:srgbClr val="2A3F6A"/>
+                      </a:solidFill>
+                      <a:prstDash val="solid"/>
+                      <a:round/>
+                      <a:headEnd type="none" w="med" len="med"/>
+                      <a:tailEnd type="none" w="med" len="med"/>
+                    </a:lnR>
+                    <a:lnT w="12700" cap="flat" cmpd="sng" algn="ctr">
+                      <a:solidFill>
+                        <a:srgbClr val="2A3F6A"/>
+                      </a:solidFill>
+                      <a:prstDash val="solid"/>
+                      <a:round/>
+                      <a:headEnd type="none" w="med" len="med"/>
+                      <a:tailEnd type="none" w="med" len="med"/>
+                    </a:lnT>
+                    <a:lnB w="12700" cap="flat" cmpd="sng" algn="ctr">
+                      <a:solidFill>
+                        <a:srgbClr val="2A3F6A"/>
+                      </a:solidFill>
+                      <a:prstDash val="solid"/>
+                      <a:round/>
+                      <a:headEnd type="none" w="med" len="med"/>
+                      <a:tailEnd type="none" w="med" len="med"/>
+                    </a:lnB>
+                    <a:solidFill>
+                      <a:srgbClr val="152440"/>
+                    </a:solidFill>
+                  </a:tcPr>
+                </a:tc>
+                <a:tc>
+                  <a:txBody>
+                    <a:bodyPr/>
+                    <a:lstStyle/>
+                    <a:p>
+                      <a:pPr algn="ctr" indent="0" marL="0">
+                        <a:buNone/>
+                      </a:pPr>
+                      <a:r>
+                        <a:rPr lang="en-US" sz="1300" dirty="0">
+                          <a:solidFill>
+                            <a:srgbClr val="FFFFFF"/>
+                          </a:solidFill>
+                          <a:latin typeface="Malgun Gothic" pitchFamily="34" charset="0"/>
+                          <a:ea typeface="Malgun Gothic" pitchFamily="34" charset="-122"/>
+                          <a:cs typeface="Malgun Gothic" pitchFamily="34" charset="-120"/>
+                        </a:rPr>
+                        <a:t>2320s</a:t>
+                      </a:r>
+                      <a:endParaRPr lang="en-US" sz="1300" dirty="0">
+                        <a:latin typeface="Malgun Gothic" charset="0"/>
+                        <a:ea typeface="Malgun Gothic" charset="0"/>
+                        <a:cs typeface="Malgun Gothic" charset="0"/>
+                      </a:endParaRPr>
+                    </a:p>
+                  </a:txBody>
+                  <a:tcPr marL="91440" marR="91440" marT="45720" marB="45720">
+                    <a:lnL w="12700" cap="flat" cmpd="sng" algn="ctr">
+                      <a:solidFill>
+                        <a:srgbClr val="2A3F6A"/>
+                      </a:solidFill>
+                      <a:prstDash val="solid"/>
+                      <a:round/>
+                      <a:headEnd type="none" w="med" len="med"/>
+                      <a:tailEnd type="none" w="med" len="med"/>
+                    </a:lnL>
+                    <a:lnR w="12700" cap="flat" cmpd="sng" algn="ctr">
+                      <a:solidFill>
+                        <a:srgbClr val="2A3F6A"/>
+                      </a:solidFill>
+                      <a:prstDash val="solid"/>
+                      <a:round/>
+                      <a:headEnd type="none" w="med" len="med"/>
+                      <a:tailEnd type="none" w="med" len="med"/>
+                    </a:lnR>
+                    <a:lnT w="12700" cap="flat" cmpd="sng" algn="ctr">
+                      <a:solidFill>
+                        <a:srgbClr val="2A3F6A"/>
+                      </a:solidFill>
+                      <a:prstDash val="solid"/>
+                      <a:round/>
+                      <a:headEnd type="none" w="med" len="med"/>
+                      <a:tailEnd type="none" w="med" len="med"/>
+                    </a:lnT>
+                    <a:lnB w="12700" cap="flat" cmpd="sng" algn="ctr">
+                      <a:solidFill>
+                        <a:srgbClr val="2A3F6A"/>
+                      </a:solidFill>
+                      <a:prstDash val="solid"/>
+                      <a:round/>
+                      <a:headEnd type="none" w="med" len="med"/>
+                      <a:tailEnd type="none" w="med" len="med"/>
+                    </a:lnB>
+                    <a:solidFill>
+                      <a:srgbClr val="152440"/>
+                    </a:solidFill>
+                  </a:tcPr>
+                </a:tc>
+                <a:tc>
+                  <a:txBody>
+                    <a:bodyPr/>
+                    <a:lstStyle/>
+                    <a:p>
+                      <a:pPr algn="ctr" indent="0" marL="0">
+                        <a:buNone/>
+                      </a:pPr>
+                      <a:r>
+                        <a:rPr lang="en-US" sz="1300" b="1" dirty="0">
+                          <a:solidFill>
+                            <a:srgbClr val="FBBF24"/>
+                          </a:solidFill>
+                          <a:latin typeface="Malgun Gothic" pitchFamily="34" charset="0"/>
+                          <a:ea typeface="Malgun Gothic" pitchFamily="34" charset="-122"/>
+                          <a:cs typeface="Malgun Gothic" pitchFamily="34" charset="-120"/>
+                        </a:rPr>
+                        <a:t>2.6x ↓</a:t>
+                      </a:r>
+                      <a:endParaRPr lang="en-US" sz="1300" dirty="0">
+                        <a:latin typeface="Malgun Gothic" charset="0"/>
+                        <a:ea typeface="Malgun Gothic" charset="0"/>
+                        <a:cs typeface="Malgun Gothic" charset="0"/>
+                      </a:endParaRPr>
+                    </a:p>
+                  </a:txBody>
+                  <a:tcPr marL="91440" marR="91440" marT="45720" marB="45720">
+                    <a:lnL w="12700" cap="flat" cmpd="sng" algn="ctr">
+                      <a:solidFill>
+                        <a:srgbClr val="2A3F6A"/>
+                      </a:solidFill>
+                      <a:prstDash val="solid"/>
+                      <a:round/>
+                      <a:headEnd type="none" w="med" len="med"/>
+                      <a:tailEnd type="none" w="med" len="med"/>
+                    </a:lnL>
+                    <a:lnR w="12700" cap="flat" cmpd="sng" algn="ctr">
+                      <a:solidFill>
+                        <a:srgbClr val="2A3F6A"/>
+                      </a:solidFill>
+                      <a:prstDash val="solid"/>
+                      <a:round/>
+                      <a:headEnd type="none" w="med" len="med"/>
+                      <a:tailEnd type="none" w="med" len="med"/>
+                    </a:lnR>
+                    <a:lnT w="12700" cap="flat" cmpd="sng" algn="ctr">
+                      <a:solidFill>
+                        <a:srgbClr val="2A3F6A"/>
+                      </a:solidFill>
+                      <a:prstDash val="solid"/>
+                      <a:round/>
+                      <a:headEnd type="none" w="med" len="med"/>
+                      <a:tailEnd type="none" w="med" len="med"/>
+                    </a:lnT>
+                    <a:lnB w="12700" cap="flat" cmpd="sng" algn="ctr">
+                      <a:solidFill>
+                        <a:srgbClr val="2A3F6A"/>
+                      </a:solidFill>
+                      <a:prstDash val="solid"/>
+                      <a:round/>
+                      <a:headEnd type="none" w="med" len="med"/>
+                      <a:tailEnd type="none" w="med" len="med"/>
+                    </a:lnB>
+                    <a:solidFill>
+                      <a:srgbClr val="152440"/>
+                    </a:solidFill>
+                  </a:tcPr>
+                </a:tc>
+              </a:tr>
+              <a:tr h="411480">
+                <a:tc>
+                  <a:txBody>
+                    <a:bodyPr/>
+                    <a:lstStyle/>
+                    <a:p>
+                      <a:pPr algn="l" indent="0" marL="0">
+                        <a:buNone/>
+                      </a:pPr>
+                      <a:r>
+                        <a:rPr lang="en-US" sz="1300" dirty="0">
+                          <a:solidFill>
+                            <a:srgbClr val="FFFFFF"/>
+                          </a:solidFill>
+                          <a:latin typeface="Malgun Gothic" pitchFamily="34" charset="0"/>
+                          <a:ea typeface="Malgun Gothic" pitchFamily="34" charset="-122"/>
+                          <a:cs typeface="Malgun Gothic" pitchFamily="34" charset="-120"/>
+                        </a:rPr>
+                        <a:t>MATH500 Scaled (tokens)</a:t>
+                      </a:r>
+                      <a:endParaRPr lang="en-US" sz="1300" dirty="0">
+                        <a:latin typeface="Malgun Gothic" charset="0"/>
+                        <a:ea typeface="Malgun Gothic" charset="0"/>
+                        <a:cs typeface="Malgun Gothic" charset="0"/>
+                      </a:endParaRPr>
+                    </a:p>
+                  </a:txBody>
+                  <a:tcPr marL="91440" marR="91440" marT="45720" marB="45720">
+                    <a:lnL w="12700" cap="flat" cmpd="sng" algn="ctr">
+                      <a:solidFill>
+                        <a:srgbClr val="2A3F6A"/>
+                      </a:solidFill>
+                      <a:prstDash val="solid"/>
+                      <a:round/>
+                      <a:headEnd type="none" w="med" len="med"/>
+                      <a:tailEnd type="none" w="med" len="med"/>
+                    </a:lnL>
+                    <a:lnR w="12700" cap="flat" cmpd="sng" algn="ctr">
+                      <a:solidFill>
+                        <a:srgbClr val="2A3F6A"/>
+                      </a:solidFill>
+                      <a:prstDash val="solid"/>
+                      <a:round/>
+                      <a:headEnd type="none" w="med" len="med"/>
+                      <a:tailEnd type="none" w="med" len="med"/>
+                    </a:lnR>
+                    <a:lnT w="12700" cap="flat" cmpd="sng" algn="ctr">
+                      <a:solidFill>
+                        <a:srgbClr val="2A3F6A"/>
+                      </a:solidFill>
+                      <a:prstDash val="solid"/>
+                      <a:round/>
+                      <a:headEnd type="none" w="med" len="med"/>
+                      <a:tailEnd type="none" w="med" len="med"/>
+                    </a:lnT>
+                    <a:lnB w="12700" cap="flat" cmpd="sng" algn="ctr">
+                      <a:solidFill>
+                        <a:srgbClr val="2A3F6A"/>
+                      </a:solidFill>
+                      <a:prstDash val="solid"/>
+                      <a:round/>
+                      <a:headEnd type="none" w="med" len="med"/>
+                      <a:tailEnd type="none" w="med" len="med"/>
+                    </a:lnB>
+                    <a:solidFill>
+                      <a:srgbClr val="1A2F52"/>
+                    </a:solidFill>
+                  </a:tcPr>
+                </a:tc>
+                <a:tc>
+                  <a:txBody>
+                    <a:bodyPr/>
+                    <a:lstStyle/>
+                    <a:p>
+                      <a:pPr algn="ctr" indent="0" marL="0">
+                        <a:buNone/>
+                      </a:pPr>
+                      <a:r>
+                        <a:rPr lang="en-US" sz="1300" dirty="0">
+                          <a:solidFill>
+                            <a:srgbClr val="FFFFFF"/>
+                          </a:solidFill>
+                          <a:latin typeface="Malgun Gothic" pitchFamily="34" charset="0"/>
+                          <a:ea typeface="Malgun Gothic" pitchFamily="34" charset="-122"/>
+                          <a:cs typeface="Malgun Gothic" pitchFamily="34" charset="-120"/>
+                        </a:rPr>
+                        <a:t>4100</a:t>
+                      </a:r>
+                      <a:endParaRPr lang="en-US" sz="1300" dirty="0">
+                        <a:latin typeface="Malgun Gothic" charset="0"/>
+                        <a:ea typeface="Malgun Gothic" charset="0"/>
+                        <a:cs typeface="Malgun Gothic" charset="0"/>
+                      </a:endParaRPr>
+                    </a:p>
+                  </a:txBody>
+                  <a:tcPr marL="91440" marR="91440" marT="45720" marB="45720">
+                    <a:lnL w="12700" cap="flat" cmpd="sng" algn="ctr">
+                      <a:solidFill>
+                        <a:srgbClr val="2A3F6A"/>
+                      </a:solidFill>
+                      <a:prstDash val="solid"/>
+                      <a:round/>
+                      <a:headEnd type="none" w="med" len="med"/>
+                      <a:tailEnd type="none" w="med" len="med"/>
+                    </a:lnL>
+                    <a:lnR w="12700" cap="flat" cmpd="sng" algn="ctr">
+                      <a:solidFill>
+                        <a:srgbClr val="2A3F6A"/>
+                      </a:solidFill>
+                      <a:prstDash val="solid"/>
+                      <a:round/>
+                      <a:headEnd type="none" w="med" len="med"/>
+                      <a:tailEnd type="none" w="med" len="med"/>
+                    </a:lnR>
+                    <a:lnT w="12700" cap="flat" cmpd="sng" algn="ctr">
+                      <a:solidFill>
+                        <a:srgbClr val="2A3F6A"/>
+                      </a:solidFill>
+                      <a:prstDash val="solid"/>
+                      <a:round/>
+                      <a:headEnd type="none" w="med" len="med"/>
+                      <a:tailEnd type="none" w="med" len="med"/>
+                    </a:lnT>
+                    <a:lnB w="12700" cap="flat" cmpd="sng" algn="ctr">
+                      <a:solidFill>
+                        <a:srgbClr val="2A3F6A"/>
+                      </a:solidFill>
+                      <a:prstDash val="solid"/>
+                      <a:round/>
+                      <a:headEnd type="none" w="med" len="med"/>
+                      <a:tailEnd type="none" w="med" len="med"/>
+                    </a:lnB>
+                    <a:solidFill>
+                      <a:srgbClr val="1A2F52"/>
+                    </a:solidFill>
+                  </a:tcPr>
+                </a:tc>
+                <a:tc>
+                  <a:txBody>
+                    <a:bodyPr/>
+                    <a:lstStyle/>
+                    <a:p>
+                      <a:pPr algn="ctr" indent="0" marL="0">
+                        <a:buNone/>
+                      </a:pPr>
+                      <a:r>
+                        <a:rPr lang="en-US" sz="1300" dirty="0">
+                          <a:solidFill>
+                            <a:srgbClr val="FFFFFF"/>
+                          </a:solidFill>
+                          <a:latin typeface="Malgun Gothic" pitchFamily="34" charset="0"/>
+                          <a:ea typeface="Malgun Gothic" pitchFamily="34" charset="-122"/>
+                          <a:cs typeface="Malgun Gothic" pitchFamily="34" charset="-120"/>
+                        </a:rPr>
+                        <a:t>893</a:t>
+                      </a:r>
+                      <a:endParaRPr lang="en-US" sz="1300" dirty="0">
+                        <a:latin typeface="Malgun Gothic" charset="0"/>
+                        <a:ea typeface="Malgun Gothic" charset="0"/>
+                        <a:cs typeface="Malgun Gothic" charset="0"/>
+                      </a:endParaRPr>
+                    </a:p>
+                  </a:txBody>
+                  <a:tcPr marL="91440" marR="91440" marT="45720" marB="45720">
+                    <a:lnL w="12700" cap="flat" cmpd="sng" algn="ctr">
+                      <a:solidFill>
+                        <a:srgbClr val="2A3F6A"/>
+                      </a:solidFill>
+                      <a:prstDash val="solid"/>
+                      <a:round/>
+                      <a:headEnd type="none" w="med" len="med"/>
+                      <a:tailEnd type="none" w="med" len="med"/>
+                    </a:lnL>
+                    <a:lnR w="12700" cap="flat" cmpd="sng" algn="ctr">
+                      <a:solidFill>
+                        <a:srgbClr val="2A3F6A"/>
+                      </a:solidFill>
+                      <a:prstDash val="solid"/>
+                      <a:round/>
+                      <a:headEnd type="none" w="med" len="med"/>
+                      <a:tailEnd type="none" w="med" len="med"/>
+                    </a:lnR>
+                    <a:lnT w="12700" cap="flat" cmpd="sng" algn="ctr">
+                      <a:solidFill>
+                        <a:srgbClr val="2A3F6A"/>
+                      </a:solidFill>
+                      <a:prstDash val="solid"/>
+                      <a:round/>
+                      <a:headEnd type="none" w="med" len="med"/>
+                      <a:tailEnd type="none" w="med" len="med"/>
+                    </a:lnT>
+                    <a:lnB w="12700" cap="flat" cmpd="sng" algn="ctr">
+                      <a:solidFill>
+                        <a:srgbClr val="2A3F6A"/>
+                      </a:solidFill>
+                      <a:prstDash val="solid"/>
+                      <a:round/>
+                      <a:headEnd type="none" w="med" len="med"/>
+                      <a:tailEnd type="none" w="med" len="med"/>
+                    </a:lnB>
+                    <a:solidFill>
+                      <a:srgbClr val="1A2F52"/>
+                    </a:solidFill>
+                  </a:tcPr>
+                </a:tc>
+                <a:tc>
+                  <a:txBody>
+                    <a:bodyPr/>
+                    <a:lstStyle/>
+                    <a:p>
+                      <a:pPr algn="ctr" indent="0" marL="0">
+                        <a:buNone/>
+                      </a:pPr>
+                      <a:r>
+                        <a:rPr lang="en-US" sz="1300" b="1" dirty="0">
+                          <a:solidFill>
+                            <a:srgbClr val="FBBF24"/>
+                          </a:solidFill>
+                          <a:latin typeface="Malgun Gothic" pitchFamily="34" charset="0"/>
+                          <a:ea typeface="Malgun Gothic" pitchFamily="34" charset="-122"/>
+                          <a:cs typeface="Malgun Gothic" pitchFamily="34" charset="-120"/>
+                        </a:rPr>
+                        <a:t>78% ↓</a:t>
+                      </a:r>
+                      <a:endParaRPr lang="en-US" sz="1300" dirty="0">
+                        <a:latin typeface="Malgun Gothic" charset="0"/>
+                        <a:ea typeface="Malgun Gothic" charset="0"/>
+                        <a:cs typeface="Malgun Gothic" charset="0"/>
+                      </a:endParaRPr>
+                    </a:p>
+                  </a:txBody>
+                  <a:tcPr marL="91440" marR="91440" marT="45720" marB="45720">
+                    <a:lnL w="12700" cap="flat" cmpd="sng" algn="ctr">
+                      <a:solidFill>
+                        <a:srgbClr val="2A3F6A"/>
+                      </a:solidFill>
+                      <a:prstDash val="solid"/>
+                      <a:round/>
+                      <a:headEnd type="none" w="med" len="med"/>
+                      <a:tailEnd type="none" w="med" len="med"/>
+                    </a:lnL>
+                    <a:lnR w="12700" cap="flat" cmpd="sng" algn="ctr">
+                      <a:solidFill>
+                        <a:srgbClr val="2A3F6A"/>
+                      </a:solidFill>
+                      <a:prstDash val="solid"/>
+                      <a:round/>
+                      <a:headEnd type="none" w="med" len="med"/>
+                      <a:tailEnd type="none" w="med" len="med"/>
+                    </a:lnR>
+                    <a:lnT w="12700" cap="flat" cmpd="sng" algn="ctr">
+                      <a:solidFill>
+                        <a:srgbClr val="2A3F6A"/>
+                      </a:solidFill>
+                      <a:prstDash val="solid"/>
+                      <a:round/>
+                      <a:headEnd type="none" w="med" len="med"/>
+                      <a:tailEnd type="none" w="med" len="med"/>
+                    </a:lnT>
+                    <a:lnB w="12700" cap="flat" cmpd="sng" algn="ctr">
+                      <a:solidFill>
+                        <a:srgbClr val="2A3F6A"/>
+                      </a:solidFill>
+                      <a:prstDash val="solid"/>
+                      <a:round/>
+                      <a:headEnd type="none" w="med" len="med"/>
+                      <a:tailEnd type="none" w="med" len="med"/>
+                    </a:lnB>
+                    <a:solidFill>
+                      <a:srgbClr val="1A2F52"/>
+                    </a:solidFill>
+                  </a:tcPr>
+                </a:tc>
+              </a:tr>
+            </a:tbl>
+          </a:graphicData>
+        </a:graphic>
+      </p:graphicFrame>
+      <p:sp>
+        <p:nvSpPr>
+          <p:cNvPr id="17" name="Shape 14"/>
+          <p:cNvSpPr/>
+          <p:nvPr/>
+        </p:nvSpPr>
+        <p:spPr>
+          <a:xfrm>
+            <a:off x="457200" y="3703320"/>
+            <a:ext cx="8229600" cy="822960"/>
+          </a:xfrm>
+          <a:prstGeom prst="rect">
+            <a:avLst/>
+          </a:prstGeom>
+          <a:solidFill>
+            <a:srgbClr val="1A2F52"/>
+          </a:solidFill>
+          <a:ln w="19050">
+            <a:solidFill>
+              <a:srgbClr val="10B981"/>
+            </a:solidFill>
+            <a:prstDash val="solid"/>
+          </a:ln>
+        </p:spPr>
+      </p:sp>
+      <p:sp>
+        <p:nvSpPr>
+          <p:cNvPr id="18" name="Text 15"/>
+          <p:cNvSpPr/>
+          <p:nvPr/>
+        </p:nvSpPr>
+        <p:spPr>
+          <a:xfrm>
+            <a:off x="640080" y="3703320"/>
+            <a:ext cx="7863840" cy="822960"/>
+          </a:xfrm>
+          <a:prstGeom prst="rect">
+            <a:avLst/>
+          </a:prstGeom>
+          <a:noFill/>
+          <a:ln/>
+        </p:spPr>
+        <p:txBody>
+          <a:bodyPr wrap="square" lIns="101600" tIns="101600" rIns="101600" bIns="101600" rtlCol="0" anchor="ctr"/>
+          <a:lstStyle/>
+          <a:p>
+            <a:pPr indent="0" marL="0">
+              <a:buNone/>
+            </a:pPr>
+            <a:r>
+              <a:rPr lang="en-US" sz="1300" b="1" dirty="0">
+                <a:solidFill>
+                  <a:srgbClr val="10B981"/>
+                </a:solidFill>
+                <a:latin typeface="Malgun Gothic" pitchFamily="34" charset="0"/>
+                <a:ea typeface="Malgun Gothic" pitchFamily="34" charset="-122"/>
+                <a:cs typeface="Malgun Gothic" pitchFamily="34" charset="-120"/>
+              </a:rPr>
+              <a:t>평균 +8.3% 정확도 / 1.2-2.4x 추론 가속 / 토큰 34.6-75.6% 감소 / 비용 $4.27 (vs LoRA $6.64, Full-SFT $9.67)</a:t>
+            </a:r>
+            <a:pPr indent="0" marL="0">
+              <a:buNone/>
+            </a:pPr>
+            <a:r>
+              <a:rPr lang="en-US" sz="1300" dirty="0">
+                <a:solidFill>
+                  <a:srgbClr val="FFFFFF"/>
+                </a:solidFill>
+                <a:latin typeface="Malgun Gothic" pitchFamily="34" charset="0"/>
+                <a:ea typeface="Malgun Gothic" pitchFamily="34" charset="-122"/>
+                <a:cs typeface="Malgun Gothic" pitchFamily="34" charset="-120"/>
+              </a:rPr>
+              <a:t/>
+            </a:r>
+            <a:endParaRPr lang="en-US" sz="1300" dirty="0"/>
+          </a:p>
+        </p:txBody>
+      </p:sp>
+    </p:spTree>
+  </p:cSld>
+  <p:clrMapOvr>
+    <a:masterClrMapping/>
+  </p:clrMapOvr>
+</p:sld>
+</file>
+
+<file path=ppt/slides/slide14.xml><?xml version="1.0" encoding="utf-8"?>
 <p:sld xmlns:a="http://schemas.openxmlformats.org/drawingml/2006/main" xmlns:r="http://schemas.openxmlformats.org/officeDocument/2006/relationships" xmlns:p="http://schemas.openxmlformats.org/presentationml/2006/main">
   <p:cSld name="Slide 12">
     <p:bg>
@@ -5436,6 +8025,10 @@
             <a:prstDash val="solid"/>
           </a:ln>
         </p:spPr>
+        <p:txBody>
+          <a:bodyPr/>
+          <a:p/>
+        </p:txBody>
       </p:sp>
       <p:sp>
         <p:nvSpPr>
@@ -5470,7 +8063,7 @@
                 <a:ea typeface="Malgun Gothic" pitchFamily="34" charset="-122"/>
                 <a:cs typeface="Malgun Gothic" pitchFamily="34" charset="-120"/>
               </a:rPr>
-              <a:t>Latent Reasoning의 4가지 흐름</a:t>
+              <a:t>Latent Reasoning의 5가지 흐름</a:t>
             </a:r>
             <a:endParaRPr lang="en-US" sz="2800" dirty="0"/>
           </a:p>
@@ -5500,6 +8093,10 @@
             <a:prstDash val="solid"/>
           </a:ln>
         </p:spPr>
+        <p:txBody>
+          <a:bodyPr/>
+          <a:p/>
+        </p:txBody>
       </p:sp>
       <p:graphicFrame>
         <p:nvGraphicFramePr>
@@ -7240,6 +9837,348 @@
                   </a:tcPr>
                 </a:tc>
               </a:tr>
+              <a:tr h="585216">
+                <a:tc>
+                  <a:txBody>
+                    <a:bodyPr/>
+                    <a:lstStyle/>
+                    <a:p>
+                      <a:pPr algn="l" indent="0" marL="0">
+                        <a:buNone/>
+                      </a:pPr>
+                      <a:r>
+                        <a:rPr lang="en-US" sz="1200" b="1" dirty="0">
+                          <a:solidFill>
+                            <a:srgbClr val="FBBF24"/>
+                          </a:solidFill>
+                          <a:latin typeface="Malgun Gothic" pitchFamily="34" charset="0"/>
+                          <a:ea typeface="Malgun Gothic" pitchFamily="34" charset="-122"/>
+                          <a:cs typeface="Malgun Gothic" pitchFamily="34" charset="-120"/>
+                        </a:rPr>
+                        <a:t>Multi-Agent Latent</a:t>
+                      </a:r>
+                      <a:endParaRPr lang="en-US" sz="1200" dirty="0">
+                        <a:latin typeface="Malgun Gothic" charset="0"/>
+                        <a:ea typeface="Malgun Gothic" charset="0"/>
+                        <a:cs typeface="Malgun Gothic" charset="0"/>
+                      </a:endParaRPr>
+                    </a:p>
+                  </a:txBody>
+                  <a:tcPr marL="91440" marR="91440" marT="45720" marB="45720">
+                    <a:lnL w="12700" cap="flat" cmpd="sng" algn="ctr">
+                      <a:solidFill>
+                        <a:srgbClr val="2A3F6A"/>
+                      </a:solidFill>
+                      <a:prstDash val="solid"/>
+                      <a:round/>
+                      <a:headEnd type="none" w="med" len="med"/>
+                      <a:tailEnd type="none" w="med" len="med"/>
+                    </a:lnL>
+                    <a:lnR w="12700" cap="flat" cmpd="sng" algn="ctr">
+                      <a:solidFill>
+                        <a:srgbClr val="2A3F6A"/>
+                      </a:solidFill>
+                      <a:prstDash val="solid"/>
+                      <a:round/>
+                      <a:headEnd type="none" w="med" len="med"/>
+                      <a:tailEnd type="none" w="med" len="med"/>
+                    </a:lnR>
+                    <a:lnT w="12700" cap="flat" cmpd="sng" algn="ctr">
+                      <a:solidFill>
+                        <a:srgbClr val="2A3F6A"/>
+                      </a:solidFill>
+                      <a:prstDash val="solid"/>
+                      <a:round/>
+                      <a:headEnd type="none" w="med" len="med"/>
+                      <a:tailEnd type="none" w="med" len="med"/>
+                    </a:lnT>
+                    <a:lnB w="12700" cap="flat" cmpd="sng" algn="ctr">
+                      <a:solidFill>
+                        <a:srgbClr val="2A3F6A"/>
+                      </a:solidFill>
+                      <a:prstDash val="solid"/>
+                      <a:round/>
+                      <a:headEnd type="none" w="med" len="med"/>
+                      <a:tailEnd type="none" w="med" len="med"/>
+                    </a:lnB>
+                    <a:solidFill>
+                      <a:srgbClr val="1A2F52"/>
+                    </a:solidFill>
+                  </a:tcPr>
+                </a:tc>
+                <a:tc>
+                  <a:txBody>
+                    <a:bodyPr/>
+                    <a:lstStyle/>
+                    <a:p>
+                      <a:pPr algn="ctr" indent="0" marL="0">
+                        <a:buNone/>
+                      </a:pPr>
+                      <a:r>
+                        <a:rPr lang="en-US" sz="1200" dirty="0">
+                          <a:solidFill>
+                            <a:srgbClr val="FFFFFF"/>
+                          </a:solidFill>
+                          <a:latin typeface="Malgun Gothic" pitchFamily="34" charset="0"/>
+                          <a:ea typeface="Malgun Gothic" pitchFamily="34" charset="-122"/>
+                          <a:cs typeface="Malgun Gothic" pitchFamily="34" charset="-120"/>
+                        </a:rPr>
+                        <a:t>RecursiveMAS</a:t>
+                      </a:r>
+                      <a:endParaRPr lang="en-US" sz="1200" dirty="0">
+                        <a:latin typeface="Malgun Gothic" charset="0"/>
+                        <a:ea typeface="Malgun Gothic" charset="0"/>
+                        <a:cs typeface="Malgun Gothic" charset="0"/>
+                      </a:endParaRPr>
+                    </a:p>
+                  </a:txBody>
+                  <a:tcPr marL="91440" marR="91440" marT="45720" marB="45720">
+                    <a:lnL w="12700" cap="flat" cmpd="sng" algn="ctr">
+                      <a:solidFill>
+                        <a:srgbClr val="2A3F6A"/>
+                      </a:solidFill>
+                      <a:prstDash val="solid"/>
+                      <a:round/>
+                      <a:headEnd type="none" w="med" len="med"/>
+                      <a:tailEnd type="none" w="med" len="med"/>
+                    </a:lnL>
+                    <a:lnR w="12700" cap="flat" cmpd="sng" algn="ctr">
+                      <a:solidFill>
+                        <a:srgbClr val="2A3F6A"/>
+                      </a:solidFill>
+                      <a:prstDash val="solid"/>
+                      <a:round/>
+                      <a:headEnd type="none" w="med" len="med"/>
+                      <a:tailEnd type="none" w="med" len="med"/>
+                    </a:lnR>
+                    <a:lnT w="12700" cap="flat" cmpd="sng" algn="ctr">
+                      <a:solidFill>
+                        <a:srgbClr val="2A3F6A"/>
+                      </a:solidFill>
+                      <a:prstDash val="solid"/>
+                      <a:round/>
+                      <a:headEnd type="none" w="med" len="med"/>
+                      <a:tailEnd type="none" w="med" len="med"/>
+                    </a:lnT>
+                    <a:lnB w="12700" cap="flat" cmpd="sng" algn="ctr">
+                      <a:solidFill>
+                        <a:srgbClr val="2A3F6A"/>
+                      </a:solidFill>
+                      <a:prstDash val="solid"/>
+                      <a:round/>
+                      <a:headEnd type="none" w="med" len="med"/>
+                      <a:tailEnd type="none" w="med" len="med"/>
+                    </a:lnB>
+                    <a:solidFill>
+                      <a:srgbClr val="1A2F52"/>
+                    </a:solidFill>
+                  </a:tcPr>
+                </a:tc>
+                <a:tc>
+                  <a:txBody>
+                    <a:bodyPr/>
+                    <a:lstStyle/>
+                    <a:p>
+                      <a:pPr algn="ctr" indent="0" marL="0">
+                        <a:buNone/>
+                      </a:pPr>
+                      <a:r>
+                        <a:rPr lang="en-US" sz="1100" dirty="0">
+                          <a:solidFill>
+                            <a:srgbClr val="FFFFFF"/>
+                          </a:solidFill>
+                          <a:latin typeface="Consolas" pitchFamily="34" charset="0"/>
+                          <a:ea typeface="Consolas" pitchFamily="34" charset="-122"/>
+                          <a:cs typeface="Consolas" pitchFamily="34" charset="-120"/>
+                        </a:rPr>
+                        <a:t>RecursiveLink (Inner/Outer)</a:t>
+                      </a:r>
+                      <a:endParaRPr lang="en-US" sz="1100" dirty="0">
+                        <a:latin typeface="Consolas" charset="0"/>
+                        <a:ea typeface="Consolas" charset="0"/>
+                        <a:cs typeface="Consolas" charset="0"/>
+                      </a:endParaRPr>
+                    </a:p>
+                  </a:txBody>
+                  <a:tcPr marL="91440" marR="91440" marT="45720" marB="45720">
+                    <a:lnL w="12700" cap="flat" cmpd="sng" algn="ctr">
+                      <a:solidFill>
+                        <a:srgbClr val="2A3F6A"/>
+                      </a:solidFill>
+                      <a:prstDash val="solid"/>
+                      <a:round/>
+                      <a:headEnd type="none" w="med" len="med"/>
+                      <a:tailEnd type="none" w="med" len="med"/>
+                    </a:lnL>
+                    <a:lnR w="12700" cap="flat" cmpd="sng" algn="ctr">
+                      <a:solidFill>
+                        <a:srgbClr val="2A3F6A"/>
+                      </a:solidFill>
+                      <a:prstDash val="solid"/>
+                      <a:round/>
+                      <a:headEnd type="none" w="med" len="med"/>
+                      <a:tailEnd type="none" w="med" len="med"/>
+                    </a:lnR>
+                    <a:lnT w="12700" cap="flat" cmpd="sng" algn="ctr">
+                      <a:solidFill>
+                        <a:srgbClr val="2A3F6A"/>
+                      </a:solidFill>
+                      <a:prstDash val="solid"/>
+                      <a:round/>
+                      <a:headEnd type="none" w="med" len="med"/>
+                      <a:tailEnd type="none" w="med" len="med"/>
+                    </a:lnT>
+                    <a:lnB w="12700" cap="flat" cmpd="sng" algn="ctr">
+                      <a:solidFill>
+                        <a:srgbClr val="2A3F6A"/>
+                      </a:solidFill>
+                      <a:prstDash val="solid"/>
+                      <a:round/>
+                      <a:headEnd type="none" w="med" len="med"/>
+                      <a:tailEnd type="none" w="med" len="med"/>
+                    </a:lnB>
+                    <a:solidFill>
+                      <a:srgbClr val="1A2F52"/>
+                    </a:solidFill>
+                  </a:tcPr>
+                </a:tc>
+                <a:tc>
+                  <a:txBody>
+                    <a:bodyPr/>
+                    <a:lstStyle/>
+                    <a:p>
+                      <a:pPr algn="ctr" indent="0" marL="0">
+                        <a:buNone/>
+                      </a:pPr>
+                      <a:r>
+                        <a:rPr lang="en-US" sz="1100" dirty="0">
+                          <a:solidFill>
+                            <a:srgbClr val="FFFFFF"/>
+                          </a:solidFill>
+                          <a:latin typeface="Malgun Gothic" pitchFamily="34" charset="0"/>
+                          <a:ea typeface="Malgun Gothic" pitchFamily="34" charset="-122"/>
+                          <a:cs typeface="Malgun Gothic" pitchFamily="34" charset="-120"/>
+                        </a:rPr>
+                        <a:t>+8.3% / 토큰 -75%</a:t>
+                      </a:r>
+                      <a:endParaRPr lang="en-US" sz="1100" dirty="0">
+                        <a:latin typeface="Malgun Gothic" charset="0"/>
+                        <a:ea typeface="Malgun Gothic" charset="0"/>
+                        <a:cs typeface="Malgun Gothic" charset="0"/>
+                      </a:endParaRPr>
+                    </a:p>
+                  </a:txBody>
+                  <a:tcPr marL="91440" marR="91440" marT="45720" marB="45720">
+                    <a:lnL w="12700" cap="flat" cmpd="sng" algn="ctr">
+                      <a:solidFill>
+                        <a:srgbClr val="2A3F6A"/>
+                      </a:solidFill>
+                      <a:prstDash val="solid"/>
+                      <a:round/>
+                      <a:headEnd type="none" w="med" len="med"/>
+                      <a:tailEnd type="none" w="med" len="med"/>
+                    </a:lnL>
+                    <a:lnR w="12700" cap="flat" cmpd="sng" algn="ctr">
+                      <a:solidFill>
+                        <a:srgbClr val="2A3F6A"/>
+                      </a:solidFill>
+                      <a:prstDash val="solid"/>
+                      <a:round/>
+                      <a:headEnd type="none" w="med" len="med"/>
+                      <a:tailEnd type="none" w="med" len="med"/>
+                    </a:lnR>
+                    <a:lnT w="12700" cap="flat" cmpd="sng" algn="ctr">
+                      <a:solidFill>
+                        <a:srgbClr val="2A3F6A"/>
+                      </a:solidFill>
+                      <a:prstDash val="solid"/>
+                      <a:round/>
+                      <a:headEnd type="none" w="med" len="med"/>
+                      <a:tailEnd type="none" w="med" len="med"/>
+                    </a:lnT>
+                    <a:lnB w="12700" cap="flat" cmpd="sng" algn="ctr">
+                      <a:solidFill>
+                        <a:srgbClr val="2A3F6A"/>
+                      </a:solidFill>
+                      <a:prstDash val="solid"/>
+                      <a:round/>
+                      <a:headEnd type="none" w="med" len="med"/>
+                      <a:tailEnd type="none" w="med" len="med"/>
+                    </a:lnB>
+                    <a:solidFill>
+                      <a:srgbClr val="1A2F52"/>
+                    </a:solidFill>
+                  </a:tcPr>
+                </a:tc>
+                <a:tc>
+                  <a:txBody>
+                    <a:bodyPr/>
+                    <a:lstStyle/>
+                    <a:p>
+                      <a:pPr algn="ctr" indent="0" marL="0">
+                        <a:buNone/>
+                      </a:pPr>
+                      <a:r>
+                        <a:rPr lang="en-US" sz="1100" dirty="0">
+                          <a:solidFill>
+                            <a:srgbClr val="A0BCD8"/>
+                          </a:solidFill>
+                          <a:latin typeface="Malgun Gothic" pitchFamily="34" charset="0"/>
+                          <a:ea typeface="Malgun Gothic" pitchFamily="34" charset="-122"/>
+                          <a:cs typeface="Malgun Gothic" pitchFamily="34" charset="-120"/>
+                        </a:rPr>
+                        <a:t>System-level</a:t>
+                      </a:r>
+                      <a:endParaRPr lang="en-US" sz="1100" dirty="0">
+                        <a:latin typeface="Malgun Gothic" charset="0"/>
+                        <a:ea typeface="Malgun Gothic" charset="0"/>
+                        <a:cs typeface="Malgun Gothic" charset="0"/>
+                      </a:endParaRPr>
+                    </a:p>
+                  </a:txBody>
+                  <a:tcPr marL="91440" marR="91440" marT="45720" marB="45720">
+                    <a:lnL w="12700" cap="flat" cmpd="sng" algn="ctr">
+                      <a:solidFill>
+                        <a:srgbClr val="2A3F6A"/>
+                      </a:solidFill>
+                      <a:prstDash val="solid"/>
+                      <a:round/>
+                      <a:headEnd type="none" w="med" len="med"/>
+                      <a:tailEnd type="none" w="med" len="med"/>
+                    </a:lnL>
+                    <a:lnR w="12700" cap="flat" cmpd="sng" algn="ctr">
+                      <a:solidFill>
+                        <a:srgbClr val="2A3F6A"/>
+                      </a:solidFill>
+                      <a:prstDash val="solid"/>
+                      <a:round/>
+                      <a:headEnd type="none" w="med" len="med"/>
+                      <a:tailEnd type="none" w="med" len="med"/>
+                    </a:lnR>
+                    <a:lnT w="12700" cap="flat" cmpd="sng" algn="ctr">
+                      <a:solidFill>
+                        <a:srgbClr val="2A3F6A"/>
+                      </a:solidFill>
+                      <a:prstDash val="solid"/>
+                      <a:round/>
+                      <a:headEnd type="none" w="med" len="med"/>
+                      <a:tailEnd type="none" w="med" len="med"/>
+                    </a:lnT>
+                    <a:lnB w="12700" cap="flat" cmpd="sng" algn="ctr">
+                      <a:solidFill>
+                        <a:srgbClr val="2A3F6A"/>
+                      </a:solidFill>
+                      <a:prstDash val="solid"/>
+                      <a:round/>
+                      <a:headEnd type="none" w="med" len="med"/>
+                      <a:tailEnd type="none" w="med" len="med"/>
+                    </a:lnB>
+                    <a:solidFill>
+                      <a:srgbClr val="1A2F52"/>
+                    </a:solidFill>
+                  </a:tcPr>
+                </a:tc>
+              </a:tr>
             </a:tbl>
           </a:graphicData>
         </a:graphic>
@@ -7268,6 +10207,10 @@
             <a:prstDash val="solid"/>
           </a:ln>
         </p:spPr>
+        <p:txBody>
+          <a:bodyPr/>
+          <a:p/>
+        </p:txBody>
       </p:sp>
       <p:sp>
         <p:nvSpPr>
@@ -7302,7 +10245,7 @@
                 <a:ea typeface="Malgun Gothic" pitchFamily="34" charset="-122"/>
                 <a:cs typeface="Malgun Gothic" pitchFamily="34" charset="-120"/>
               </a:rPr>
-              <a:t>공통 동인: </a:t>
+              <a:t>공통 동인: CoT 비효율 극복  |  Hidden state 대역폭 (~2,700x)  |  Test-time compute의 새 차원 (depth + agents)</a:t>
             </a:r>
             <a:pPr indent="0" marL="0">
               <a:buNone/>
@@ -7316,7 +10259,7 @@
                 <a:ea typeface="Malgun Gothic" pitchFamily="34" charset="-122"/>
                 <a:cs typeface="Malgun Gothic" pitchFamily="34" charset="-120"/>
               </a:rPr>
-              <a:t>CoT 비효율 극복  |  Hidden state 대역폭 활용 (~2,700x)  |  Test-time compute의 새 차원</a:t>
+              <a:t/>
             </a:r>
             <a:endParaRPr lang="en-US" sz="1200" dirty="0"/>
           </a:p>
@@ -7330,7 +10273,7 @@
 </p:sld>
 </file>
 
-<file path=ppt/slides/slide13.xml><?xml version="1.0" encoding="utf-8"?>
+<file path=ppt/slides/slide15.xml><?xml version="1.0" encoding="utf-8"?>
 <p:sld xmlns:a="http://schemas.openxmlformats.org/drawingml/2006/main" xmlns:r="http://schemas.openxmlformats.org/officeDocument/2006/relationships" xmlns:p="http://schemas.openxmlformats.org/presentationml/2006/main">
   <p:cSld name="Slide 13">
     <p:bg>
@@ -7378,6 +10321,10 @@
             <a:prstDash val="solid"/>
           </a:ln>
         </p:spPr>
+        <p:txBody>
+          <a:bodyPr/>
+          <a:p/>
+        </p:txBody>
       </p:sp>
       <p:sp>
         <p:nvSpPr>
@@ -7412,7 +10359,7 @@
                 <a:ea typeface="Malgun Gothic" pitchFamily="34" charset="-122"/>
                 <a:cs typeface="Malgun Gothic" pitchFamily="34" charset="-120"/>
               </a:rPr>
-              <a:t>5가지 열린 질문</a:t>
+              <a:t>5가지 열린 질문 (+ RecursiveMAS의 system-level 차원)</a:t>
             </a:r>
             <a:endParaRPr lang="en-US" sz="2600" dirty="0"/>
           </a:p>
@@ -7442,6 +10389,10 @@
             <a:prstDash val="solid"/>
           </a:ln>
         </p:spPr>
+        <p:txBody>
+          <a:bodyPr/>
+          <a:p/>
+        </p:txBody>
       </p:sp>
       <p:sp>
         <p:nvSpPr>
@@ -7474,6 +10425,10 @@
             </a:outerShdw>
           </a:effectLst>
         </p:spPr>
+        <p:txBody>
+          <a:bodyPr/>
+          <a:p/>
+        </p:txBody>
       </p:sp>
       <p:sp>
         <p:nvSpPr>
@@ -7499,6 +10454,10 @@
             <a:prstDash val="solid"/>
           </a:ln>
         </p:spPr>
+        <p:txBody>
+          <a:bodyPr/>
+          <a:p/>
+        </p:txBody>
       </p:sp>
       <p:sp>
         <p:nvSpPr>
@@ -7648,6 +10607,10 @@
             </a:outerShdw>
           </a:effectLst>
         </p:spPr>
+        <p:txBody>
+          <a:bodyPr/>
+          <a:p/>
+        </p:txBody>
       </p:sp>
       <p:sp>
         <p:nvSpPr>
@@ -7673,6 +10636,10 @@
             <a:prstDash val="solid"/>
           </a:ln>
         </p:spPr>
+        <p:txBody>
+          <a:bodyPr/>
+          <a:p/>
+        </p:txBody>
       </p:sp>
       <p:sp>
         <p:nvSpPr>
@@ -7822,6 +10789,10 @@
             </a:outerShdw>
           </a:effectLst>
         </p:spPr>
+        <p:txBody>
+          <a:bodyPr/>
+          <a:p/>
+        </p:txBody>
       </p:sp>
       <p:sp>
         <p:nvSpPr>
@@ -7847,6 +10818,10 @@
             <a:prstDash val="solid"/>
           </a:ln>
         </p:spPr>
+        <p:txBody>
+          <a:bodyPr/>
+          <a:p/>
+        </p:txBody>
       </p:sp>
       <p:sp>
         <p:nvSpPr>
@@ -7996,6 +10971,10 @@
             </a:outerShdw>
           </a:effectLst>
         </p:spPr>
+        <p:txBody>
+          <a:bodyPr/>
+          <a:p/>
+        </p:txBody>
       </p:sp>
       <p:sp>
         <p:nvSpPr>
@@ -8021,6 +11000,10 @@
             <a:prstDash val="solid"/>
           </a:ln>
         </p:spPr>
+        <p:txBody>
+          <a:bodyPr/>
+          <a:p/>
+        </p:txBody>
       </p:sp>
       <p:sp>
         <p:nvSpPr>
@@ -8133,7 +11116,7 @@
                 <a:ea typeface="Malgun Gothic" pitchFamily="34" charset="-122"/>
                 <a:cs typeface="Malgun Gothic" pitchFamily="34" charset="-120"/>
               </a:rPr>
-              <a:t>현재 평가는 GSM8K·ARC-AGI 중심 -&gt; latent 고유 강점 미측정</a:t>
+              <a:t>기존 벤치마크는 latent의 고유 강점 미측정 + multi-agent latent 협업 평가 부재</a:t>
             </a:r>
             <a:endParaRPr lang="en-US" sz="1100" dirty="0"/>
           </a:p>
@@ -8170,6 +11153,10 @@
             </a:outerShdw>
           </a:effectLst>
         </p:spPr>
+        <p:txBody>
+          <a:bodyPr/>
+          <a:p/>
+        </p:txBody>
       </p:sp>
       <p:sp>
         <p:nvSpPr>
@@ -8195,6 +11182,10 @@
             <a:prstDash val="solid"/>
           </a:ln>
         </p:spPr>
+        <p:txBody>
+          <a:bodyPr/>
+          <a:p/>
+        </p:txBody>
       </p:sp>
       <p:sp>
         <p:nvSpPr>
@@ -8307,7 +11298,7 @@
                 <a:ea typeface="Malgun Gothic" pitchFamily="34" charset="-122"/>
                 <a:cs typeface="Malgun Gothic" pitchFamily="34" charset="-120"/>
               </a:rPr>
-              <a:t>Internal thought = RLHF 사각지대 -&gt; misaligned reasoning 탐지 불가</a:t>
+              <a:t>Internal thought = RLHF 사각지대 -&gt; latent multi-agent collusion 탐지 불가</a:t>
             </a:r>
             <a:endParaRPr lang="en-US" sz="1100" dirty="0"/>
           </a:p>
@@ -8321,7 +11312,7 @@
 </p:sld>
 </file>
 
-<file path=ppt/slides/slide14.xml><?xml version="1.0" encoding="utf-8"?>
+<file path=ppt/slides/slide16.xml><?xml version="1.0" encoding="utf-8"?>
 <p:sld xmlns:a="http://schemas.openxmlformats.org/drawingml/2006/main" xmlns:r="http://schemas.openxmlformats.org/officeDocument/2006/relationships" xmlns:p="http://schemas.openxmlformats.org/presentationml/2006/main">
   <p:cSld name="Slide 14">
     <p:bg>
@@ -8369,6 +11360,10 @@
             <a:prstDash val="solid"/>
           </a:ln>
         </p:spPr>
+        <p:txBody>
+          <a:bodyPr/>
+          <a:p/>
+        </p:txBody>
       </p:sp>
       <p:sp>
         <p:nvSpPr>
@@ -9352,7 +12347,7 @@
                 <a:ea typeface="Malgun Gothic" pitchFamily="34" charset="-122"/>
                 <a:cs typeface="Malgun Gothic" pitchFamily="34" charset="-120"/>
               </a:rPr>
-              <a:t>LatentCoT-Horizon</a:t>
+              <a:t>RecursiveMAS</a:t>
             </a:r>
             <a:endParaRPr lang="en-US" sz="1300" dirty="0"/>
           </a:p>
@@ -9391,7 +12386,7 @@
                 <a:ea typeface="Consolas" pitchFamily="34" charset="-122"/>
                 <a:cs typeface="Consolas" pitchFamily="34" charset="-120"/>
               </a:rPr>
-              <a:t>github.com/multimodal-art-projection/LatentCoT-Horizon</a:t>
+              <a:t>arXiv:2604.25917</a:t>
             </a:r>
             <a:endParaRPr lang="en-US" sz="1100" dirty="0"/>
           </a:p>
@@ -9430,7 +12425,7 @@
                 <a:ea typeface="Malgun Gothic" pitchFamily="34" charset="-122"/>
                 <a:cs typeface="Malgun Gothic" pitchFamily="34" charset="-120"/>
               </a:rPr>
-              <a:t>M-A-P 논문 컬렉션</a:t>
+              <a:t>Yang et al., UIUC + Stanford + MIT + NVIDIA (2026-04)</a:t>
             </a:r>
             <a:endParaRPr lang="en-US" sz="1000" dirty="0"/>
           </a:p>
@@ -9556,6 +12551,10 @@
             <a:prstDash val="solid"/>
           </a:ln>
         </p:spPr>
+        <p:txBody>
+          <a:bodyPr/>
+          <a:p/>
+        </p:txBody>
       </p:sp>
       <p:sp>
         <p:nvSpPr>
@@ -10439,6 +13438,10 @@
             <a:prstDash val="solid"/>
           </a:ln>
         </p:spPr>
+        <p:txBody>
+          <a:bodyPr/>
+          <a:p/>
+        </p:txBody>
       </p:sp>
       <p:sp>
         <p:nvSpPr>
@@ -11082,6 +14085,10 @@
             <a:prstDash val="solid"/>
           </a:ln>
         </p:spPr>
+        <p:txBody>
+          <a:bodyPr/>
+          <a:p/>
+        </p:txBody>
       </p:sp>
       <p:sp>
         <p:nvSpPr>
@@ -12067,6 +15074,10 @@
             <a:prstDash val="solid"/>
           </a:ln>
         </p:spPr>
+        <p:txBody>
+          <a:bodyPr/>
+          <a:p/>
+        </p:txBody>
       </p:sp>
       <p:sp>
         <p:nvSpPr>
@@ -12958,6 +15969,10 @@
             <a:prstDash val="solid"/>
           </a:ln>
         </p:spPr>
+        <p:txBody>
+          <a:bodyPr/>
+          <a:p/>
+        </p:txBody>
       </p:sp>
       <p:sp>
         <p:nvSpPr>
@@ -14726,6 +17741,10 @@
             <a:prstDash val="solid"/>
           </a:ln>
         </p:spPr>
+        <p:txBody>
+          <a:bodyPr/>
+          <a:p/>
+        </p:txBody>
       </p:sp>
       <p:sp>
         <p:nvSpPr>
@@ -15900,6 +18919,10 @@
             <a:prstDash val="solid"/>
           </a:ln>
         </p:spPr>
+        <p:txBody>
+          <a:bodyPr/>
+          <a:p/>
+        </p:txBody>
       </p:sp>
       <p:sp>
         <p:nvSpPr>
@@ -16808,6 +19831,10 @@
             <a:prstDash val="solid"/>
           </a:ln>
         </p:spPr>
+        <p:txBody>
+          <a:bodyPr/>
+          <a:p/>
+        </p:txBody>
       </p:sp>
       <p:sp>
         <p:nvSpPr>

</xml_diff>